<commit_message>
PPT: drop instructions slide, logos on white; simplify Round 2 form and rules
Co-Authored-By: Claude Sonnet 5.5 <noreply@anthropic.com>
</commit_message>
<xml_diff>
--- a/site/downloads/DATATHON-Round1-Idea-PPT-Template.pptx
+++ b/site/downloads/DATATHON-Round1-Idea-PPT-Template.pptx
@@ -13,7 +13,6 @@
     <p:sldId id="261" r:id="rId12"/>
     <p:sldId id="262" r:id="rId13"/>
     <p:sldId id="263" r:id="rId14"/>
-    <p:sldId id="264" r:id="rId15"/>
   </p:sldIdLst>
   <p:sldSz cx="12191695" cy="6858000" type="screen4x3"/>
   <p:notesSz cx="6858000" cy="9144000"/>
@@ -3104,22 +3103,94 @@
         <p:nvPr/>
       </p:nvGrpSpPr>
       <p:grpSpPr/>
-      <p:sp>
-        <p:nvSpPr>
-          <p:cNvPr id="2" name="Rectangle 1"/>
+      <p:pic>
+        <p:nvPicPr>
+          <p:cNvPr id="2" name="Picture 1" descr="logo-dsc-light.png"/>
+          <p:cNvPicPr>
+            <a:picLocks noChangeAspect="1"/>
+          </p:cNvPicPr>
+          <p:nvPr/>
+        </p:nvPicPr>
+        <p:blipFill>
+          <a:blip r:embed="rId2"/>
+          <a:stretch>
+            <a:fillRect/>
+          </a:stretch>
+        </p:blipFill>
+        <p:spPr>
+          <a:xfrm>
+            <a:off x="640080" y="228600"/>
+            <a:ext cx="1316397" cy="1051560"/>
+          </a:xfrm>
+          <a:prstGeom prst="rect">
+            <a:avLst/>
+          </a:prstGeom>
+        </p:spPr>
+      </p:pic>
+      <p:pic>
+        <p:nvPicPr>
+          <p:cNvPr id="3" name="Picture 2" descr="logo-vitap-light.png"/>
+          <p:cNvPicPr>
+            <a:picLocks noChangeAspect="1"/>
+          </p:cNvPicPr>
+          <p:nvPr/>
+        </p:nvPicPr>
+        <p:blipFill>
+          <a:blip r:embed="rId3"/>
+          <a:stretch>
+            <a:fillRect/>
+          </a:stretch>
+        </p:blipFill>
+        <p:spPr>
+          <a:xfrm>
+            <a:off x="4480560" y="365760"/>
+            <a:ext cx="2497824" cy="777240"/>
+          </a:xfrm>
+          <a:prstGeom prst="rect">
+            <a:avLst/>
+          </a:prstGeom>
+        </p:spPr>
+      </p:pic>
+      <p:pic>
+        <p:nvPicPr>
+          <p:cNvPr id="4" name="Picture 3" descr="logo-iiec-light.png"/>
+          <p:cNvPicPr>
+            <a:picLocks noChangeAspect="1"/>
+          </p:cNvPicPr>
+          <p:nvPr/>
+        </p:nvPicPr>
+        <p:blipFill>
+          <a:blip r:embed="rId4"/>
+          <a:stretch>
+            <a:fillRect/>
+          </a:stretch>
+        </p:blipFill>
+        <p:spPr>
+          <a:xfrm>
+            <a:off x="9418320" y="365760"/>
+            <a:ext cx="2053503" cy="777240"/>
+          </a:xfrm>
+          <a:prstGeom prst="rect">
+            <a:avLst/>
+          </a:prstGeom>
+        </p:spPr>
+      </p:pic>
+      <p:sp>
+        <p:nvSpPr>
+          <p:cNvPr id="5" name="Rectangle 4"/>
           <p:cNvSpPr/>
           <p:nvPr/>
         </p:nvSpPr>
         <p:spPr>
           <a:xfrm>
-            <a:off x="0" y="0"/>
-            <a:ext cx="12191695" cy="1371600"/>
+            <a:off x="457200" y="1417320"/>
+            <a:ext cx="11274552" cy="36576"/>
           </a:xfrm>
           <a:prstGeom prst="rect">
             <a:avLst/>
           </a:prstGeom>
           <a:solidFill>
-            <a:srgbClr val="000000"/>
+            <a:srgbClr val="19E3F5"/>
           </a:solidFill>
           <a:ln>
             <a:noFill/>
@@ -3148,78 +3219,6 @@
           </a:p>
         </p:txBody>
       </p:sp>
-      <p:pic>
-        <p:nvPicPr>
-          <p:cNvPr id="3" name="Picture 2" descr="logo-dsc.png"/>
-          <p:cNvPicPr>
-            <a:picLocks noChangeAspect="1"/>
-          </p:cNvPicPr>
-          <p:nvPr/>
-        </p:nvPicPr>
-        <p:blipFill>
-          <a:blip r:embed="rId2"/>
-          <a:stretch>
-            <a:fillRect/>
-          </a:stretch>
-        </p:blipFill>
-        <p:spPr>
-          <a:xfrm>
-            <a:off x="548640" y="182880"/>
-            <a:ext cx="1259163" cy="1005840"/>
-          </a:xfrm>
-          <a:prstGeom prst="rect">
-            <a:avLst/>
-          </a:prstGeom>
-        </p:spPr>
-      </p:pic>
-      <p:pic>
-        <p:nvPicPr>
-          <p:cNvPr id="4" name="Picture 3" descr="logo-vitap.png"/>
-          <p:cNvPicPr>
-            <a:picLocks noChangeAspect="1"/>
-          </p:cNvPicPr>
-          <p:nvPr/>
-        </p:nvPicPr>
-        <p:blipFill>
-          <a:blip r:embed="rId3"/>
-          <a:stretch>
-            <a:fillRect/>
-          </a:stretch>
-        </p:blipFill>
-        <p:spPr>
-          <a:xfrm>
-            <a:off x="4572000" y="320040"/>
-            <a:ext cx="2350893" cy="731520"/>
-          </a:xfrm>
-          <a:prstGeom prst="rect">
-            <a:avLst/>
-          </a:prstGeom>
-        </p:spPr>
-      </p:pic>
-      <p:pic>
-        <p:nvPicPr>
-          <p:cNvPr id="5" name="Picture 4" descr="logo-iiec.png"/>
-          <p:cNvPicPr>
-            <a:picLocks noChangeAspect="1"/>
-          </p:cNvPicPr>
-          <p:nvPr/>
-        </p:nvPicPr>
-        <p:blipFill>
-          <a:blip r:embed="rId4"/>
-          <a:stretch>
-            <a:fillRect/>
-          </a:stretch>
-        </p:blipFill>
-        <p:spPr>
-          <a:xfrm>
-            <a:off x="9509760" y="320040"/>
-            <a:ext cx="1932709" cy="731520"/>
-          </a:xfrm>
-          <a:prstGeom prst="rect">
-            <a:avLst/>
-          </a:prstGeom>
-        </p:spPr>
-      </p:pic>
       <p:sp>
         <p:nvSpPr>
           <p:cNvPr id="6" name="TextBox 5"/>
@@ -3535,24 +3534,70 @@
           </a:p>
         </p:txBody>
       </p:sp>
-      <p:sp>
-        <p:nvSpPr>
-          <p:cNvPr id="4" name="Rounded Rectangle 3"/>
+      <p:pic>
+        <p:nvPicPr>
+          <p:cNvPr id="4" name="Picture 3" descr="logo-dsc-light.png"/>
+          <p:cNvPicPr>
+            <a:picLocks noChangeAspect="1"/>
+          </p:cNvPicPr>
+          <p:nvPr/>
+        </p:nvPicPr>
+        <p:blipFill>
+          <a:blip r:embed="rId2"/>
+          <a:stretch>
+            <a:fillRect/>
+          </a:stretch>
+        </p:blipFill>
+        <p:spPr>
+          <a:xfrm>
+            <a:off x="9326880" y="182880"/>
+            <a:ext cx="1087459" cy="868680"/>
+          </a:xfrm>
+          <a:prstGeom prst="rect">
+            <a:avLst/>
+          </a:prstGeom>
+        </p:spPr>
+      </p:pic>
+      <p:pic>
+        <p:nvPicPr>
+          <p:cNvPr id="5" name="Picture 4" descr="logo-iiec-light.png"/>
+          <p:cNvPicPr>
+            <a:picLocks noChangeAspect="1"/>
+          </p:cNvPicPr>
+          <p:nvPr/>
+        </p:nvPicPr>
+        <p:blipFill>
+          <a:blip r:embed="rId3"/>
+          <a:stretch>
+            <a:fillRect/>
+          </a:stretch>
+        </p:blipFill>
+        <p:spPr>
+          <a:xfrm>
+            <a:off x="10698480" y="384048"/>
+            <a:ext cx="1328738" cy="502920"/>
+          </a:xfrm>
+          <a:prstGeom prst="rect">
+            <a:avLst/>
+          </a:prstGeom>
+        </p:spPr>
+      </p:pic>
+      <p:sp>
+        <p:nvSpPr>
+          <p:cNvPr id="6" name="Rectangle 5"/>
           <p:cNvSpPr/>
           <p:nvPr/>
         </p:nvSpPr>
         <p:spPr>
           <a:xfrm>
-            <a:off x="9464040" y="182880"/>
-            <a:ext cx="2514600" cy="914400"/>
-          </a:xfrm>
-          <a:prstGeom prst="roundRect">
-            <a:avLst>
-              <a:gd name="adj" fmla="val 20000"/>
-            </a:avLst>
+            <a:off x="0" y="6355080"/>
+            <a:ext cx="12191695" cy="502920"/>
+          </a:xfrm>
+          <a:prstGeom prst="rect">
+            <a:avLst/>
           </a:prstGeom>
           <a:solidFill>
-            <a:srgbClr val="000000"/>
+            <a:srgbClr val="19E3F5"/>
           </a:solidFill>
           <a:ln>
             <a:noFill/>
@@ -3581,101 +3626,9 @@
           </a:p>
         </p:txBody>
       </p:sp>
-      <p:pic>
-        <p:nvPicPr>
-          <p:cNvPr id="5" name="Picture 4" descr="logo-dsc.png"/>
-          <p:cNvPicPr>
-            <a:picLocks noChangeAspect="1"/>
-          </p:cNvPicPr>
-          <p:nvPr/>
-        </p:nvPicPr>
-        <p:blipFill>
-          <a:blip r:embed="rId2"/>
-          <a:stretch>
-            <a:fillRect/>
-          </a:stretch>
-        </p:blipFill>
-        <p:spPr>
-          <a:xfrm>
-            <a:off x="9601200" y="246888"/>
-            <a:ext cx="984436" cy="786384"/>
-          </a:xfrm>
-          <a:prstGeom prst="rect">
-            <a:avLst/>
-          </a:prstGeom>
-        </p:spPr>
-      </p:pic>
-      <p:pic>
-        <p:nvPicPr>
-          <p:cNvPr id="6" name="Picture 5" descr="logo-iiec.png"/>
-          <p:cNvPicPr>
-            <a:picLocks noChangeAspect="1"/>
-          </p:cNvPicPr>
-          <p:nvPr/>
-        </p:nvPicPr>
-        <p:blipFill>
-          <a:blip r:embed="rId3"/>
-          <a:stretch>
-            <a:fillRect/>
-          </a:stretch>
-        </p:blipFill>
-        <p:spPr>
-          <a:xfrm>
-            <a:off x="10561320" y="393192"/>
-            <a:ext cx="1328738" cy="502920"/>
-          </a:xfrm>
-          <a:prstGeom prst="rect">
-            <a:avLst/>
-          </a:prstGeom>
-        </p:spPr>
-      </p:pic>
-      <p:sp>
-        <p:nvSpPr>
-          <p:cNvPr id="7" name="Rectangle 6"/>
-          <p:cNvSpPr/>
-          <p:nvPr/>
-        </p:nvSpPr>
-        <p:spPr>
-          <a:xfrm>
-            <a:off x="0" y="6355080"/>
-            <a:ext cx="12191695" cy="502920"/>
-          </a:xfrm>
-          <a:prstGeom prst="rect">
-            <a:avLst/>
-          </a:prstGeom>
-          <a:solidFill>
-            <a:srgbClr val="19E3F5"/>
-          </a:solidFill>
-          <a:ln>
-            <a:noFill/>
-          </a:ln>
-          <a:effectLst/>
-        </p:spPr>
-        <p:style>
-          <a:lnRef idx="1">
-            <a:schemeClr val="accent1"/>
-          </a:lnRef>
-          <a:fillRef idx="3">
-            <a:schemeClr val="accent1"/>
-          </a:fillRef>
-          <a:effectRef idx="2">
-            <a:schemeClr val="accent1"/>
-          </a:effectRef>
-          <a:fontRef idx="minor">
-            <a:schemeClr val="lt1"/>
-          </a:fontRef>
-        </p:style>
-        <p:txBody>
-          <a:bodyPr rtlCol="0" anchor="ctr"/>
-          <a:lstStyle/>
-          <a:p>
-            <a:pPr algn="ctr"/>
-          </a:p>
-        </p:txBody>
-      </p:sp>
-      <p:sp>
-        <p:nvSpPr>
-          <p:cNvPr id="8" name="TextBox 7"/>
+      <p:sp>
+        <p:nvSpPr>
+          <p:cNvPr id="7" name="TextBox 6"/>
           <p:cNvSpPr txBox="1"/>
           <p:nvPr/>
         </p:nvSpPr>
@@ -3710,7 +3663,7 @@
       </p:sp>
       <p:sp>
         <p:nvSpPr>
-          <p:cNvPr id="9" name="TextBox 8"/>
+          <p:cNvPr id="8" name="TextBox 7"/>
           <p:cNvSpPr txBox="1"/>
           <p:nvPr/>
         </p:nvSpPr>
@@ -3745,7 +3698,7 @@
       </p:sp>
       <p:sp>
         <p:nvSpPr>
-          <p:cNvPr id="10" name="TextBox 9"/>
+          <p:cNvPr id="9" name="TextBox 8"/>
           <p:cNvSpPr txBox="1"/>
           <p:nvPr/>
         </p:nvSpPr>
@@ -3789,7 +3742,7 @@
       </p:sp>
       <p:sp>
         <p:nvSpPr>
-          <p:cNvPr id="11" name="TextBox 10"/>
+          <p:cNvPr id="10" name="TextBox 9"/>
           <p:cNvSpPr txBox="1"/>
           <p:nvPr/>
         </p:nvSpPr>
@@ -3978,24 +3931,70 @@
           </a:p>
         </p:txBody>
       </p:sp>
-      <p:sp>
-        <p:nvSpPr>
-          <p:cNvPr id="4" name="Rounded Rectangle 3"/>
+      <p:pic>
+        <p:nvPicPr>
+          <p:cNvPr id="4" name="Picture 3" descr="logo-dsc-light.png"/>
+          <p:cNvPicPr>
+            <a:picLocks noChangeAspect="1"/>
+          </p:cNvPicPr>
+          <p:nvPr/>
+        </p:nvPicPr>
+        <p:blipFill>
+          <a:blip r:embed="rId2"/>
+          <a:stretch>
+            <a:fillRect/>
+          </a:stretch>
+        </p:blipFill>
+        <p:spPr>
+          <a:xfrm>
+            <a:off x="9326880" y="182880"/>
+            <a:ext cx="1087459" cy="868680"/>
+          </a:xfrm>
+          <a:prstGeom prst="rect">
+            <a:avLst/>
+          </a:prstGeom>
+        </p:spPr>
+      </p:pic>
+      <p:pic>
+        <p:nvPicPr>
+          <p:cNvPr id="5" name="Picture 4" descr="logo-iiec-light.png"/>
+          <p:cNvPicPr>
+            <a:picLocks noChangeAspect="1"/>
+          </p:cNvPicPr>
+          <p:nvPr/>
+        </p:nvPicPr>
+        <p:blipFill>
+          <a:blip r:embed="rId3"/>
+          <a:stretch>
+            <a:fillRect/>
+          </a:stretch>
+        </p:blipFill>
+        <p:spPr>
+          <a:xfrm>
+            <a:off x="10698480" y="384048"/>
+            <a:ext cx="1328738" cy="502920"/>
+          </a:xfrm>
+          <a:prstGeom prst="rect">
+            <a:avLst/>
+          </a:prstGeom>
+        </p:spPr>
+      </p:pic>
+      <p:sp>
+        <p:nvSpPr>
+          <p:cNvPr id="6" name="Rectangle 5"/>
           <p:cNvSpPr/>
           <p:nvPr/>
         </p:nvSpPr>
         <p:spPr>
           <a:xfrm>
-            <a:off x="9464040" y="182880"/>
-            <a:ext cx="2514600" cy="914400"/>
-          </a:xfrm>
-          <a:prstGeom prst="roundRect">
-            <a:avLst>
-              <a:gd name="adj" fmla="val 20000"/>
-            </a:avLst>
+            <a:off x="0" y="6355080"/>
+            <a:ext cx="12191695" cy="502920"/>
+          </a:xfrm>
+          <a:prstGeom prst="rect">
+            <a:avLst/>
           </a:prstGeom>
           <a:solidFill>
-            <a:srgbClr val="000000"/>
+            <a:srgbClr val="19E3F5"/>
           </a:solidFill>
           <a:ln>
             <a:noFill/>
@@ -4024,101 +4023,9 @@
           </a:p>
         </p:txBody>
       </p:sp>
-      <p:pic>
-        <p:nvPicPr>
-          <p:cNvPr id="5" name="Picture 4" descr="logo-dsc.png"/>
-          <p:cNvPicPr>
-            <a:picLocks noChangeAspect="1"/>
-          </p:cNvPicPr>
-          <p:nvPr/>
-        </p:nvPicPr>
-        <p:blipFill>
-          <a:blip r:embed="rId2"/>
-          <a:stretch>
-            <a:fillRect/>
-          </a:stretch>
-        </p:blipFill>
-        <p:spPr>
-          <a:xfrm>
-            <a:off x="9601200" y="246888"/>
-            <a:ext cx="984436" cy="786384"/>
-          </a:xfrm>
-          <a:prstGeom prst="rect">
-            <a:avLst/>
-          </a:prstGeom>
-        </p:spPr>
-      </p:pic>
-      <p:pic>
-        <p:nvPicPr>
-          <p:cNvPr id="6" name="Picture 5" descr="logo-iiec.png"/>
-          <p:cNvPicPr>
-            <a:picLocks noChangeAspect="1"/>
-          </p:cNvPicPr>
-          <p:nvPr/>
-        </p:nvPicPr>
-        <p:blipFill>
-          <a:blip r:embed="rId3"/>
-          <a:stretch>
-            <a:fillRect/>
-          </a:stretch>
-        </p:blipFill>
-        <p:spPr>
-          <a:xfrm>
-            <a:off x="10561320" y="393192"/>
-            <a:ext cx="1328738" cy="502920"/>
-          </a:xfrm>
-          <a:prstGeom prst="rect">
-            <a:avLst/>
-          </a:prstGeom>
-        </p:spPr>
-      </p:pic>
-      <p:sp>
-        <p:nvSpPr>
-          <p:cNvPr id="7" name="Rectangle 6"/>
-          <p:cNvSpPr/>
-          <p:nvPr/>
-        </p:nvSpPr>
-        <p:spPr>
-          <a:xfrm>
-            <a:off x="0" y="6355080"/>
-            <a:ext cx="12191695" cy="502920"/>
-          </a:xfrm>
-          <a:prstGeom prst="rect">
-            <a:avLst/>
-          </a:prstGeom>
-          <a:solidFill>
-            <a:srgbClr val="19E3F5"/>
-          </a:solidFill>
-          <a:ln>
-            <a:noFill/>
-          </a:ln>
-          <a:effectLst/>
-        </p:spPr>
-        <p:style>
-          <a:lnRef idx="1">
-            <a:schemeClr val="accent1"/>
-          </a:lnRef>
-          <a:fillRef idx="3">
-            <a:schemeClr val="accent1"/>
-          </a:fillRef>
-          <a:effectRef idx="2">
-            <a:schemeClr val="accent1"/>
-          </a:effectRef>
-          <a:fontRef idx="minor">
-            <a:schemeClr val="lt1"/>
-          </a:fontRef>
-        </p:style>
-        <p:txBody>
-          <a:bodyPr rtlCol="0" anchor="ctr"/>
-          <a:lstStyle/>
-          <a:p>
-            <a:pPr algn="ctr"/>
-          </a:p>
-        </p:txBody>
-      </p:sp>
-      <p:sp>
-        <p:nvSpPr>
-          <p:cNvPr id="8" name="TextBox 7"/>
+      <p:sp>
+        <p:nvSpPr>
+          <p:cNvPr id="7" name="TextBox 6"/>
           <p:cNvSpPr txBox="1"/>
           <p:nvPr/>
         </p:nvSpPr>
@@ -4153,7 +4060,7 @@
       </p:sp>
       <p:sp>
         <p:nvSpPr>
-          <p:cNvPr id="9" name="TextBox 8"/>
+          <p:cNvPr id="8" name="TextBox 7"/>
           <p:cNvSpPr txBox="1"/>
           <p:nvPr/>
         </p:nvSpPr>
@@ -4188,7 +4095,7 @@
       </p:sp>
       <p:sp>
         <p:nvSpPr>
-          <p:cNvPr id="10" name="TextBox 9"/>
+          <p:cNvPr id="9" name="TextBox 8"/>
           <p:cNvSpPr txBox="1"/>
           <p:nvPr/>
         </p:nvSpPr>
@@ -4232,7 +4139,7 @@
       </p:sp>
       <p:sp>
         <p:nvSpPr>
-          <p:cNvPr id="11" name="TextBox 10"/>
+          <p:cNvPr id="10" name="TextBox 9"/>
           <p:cNvSpPr txBox="1"/>
           <p:nvPr/>
         </p:nvSpPr>
@@ -4291,7 +4198,7 @@
       </p:sp>
       <p:sp>
         <p:nvSpPr>
-          <p:cNvPr id="12" name="TextBox 11"/>
+          <p:cNvPr id="11" name="TextBox 10"/>
           <p:cNvSpPr txBox="1"/>
           <p:nvPr/>
         </p:nvSpPr>
@@ -4344,7 +4251,7 @@
       </p:sp>
       <p:sp>
         <p:nvSpPr>
-          <p:cNvPr id="13" name="TextBox 12"/>
+          <p:cNvPr id="12" name="TextBox 11"/>
           <p:cNvSpPr txBox="1"/>
           <p:nvPr/>
         </p:nvSpPr>
@@ -4515,24 +4422,70 @@
           </a:p>
         </p:txBody>
       </p:sp>
-      <p:sp>
-        <p:nvSpPr>
-          <p:cNvPr id="4" name="Rounded Rectangle 3"/>
+      <p:pic>
+        <p:nvPicPr>
+          <p:cNvPr id="4" name="Picture 3" descr="logo-dsc-light.png"/>
+          <p:cNvPicPr>
+            <a:picLocks noChangeAspect="1"/>
+          </p:cNvPicPr>
+          <p:nvPr/>
+        </p:nvPicPr>
+        <p:blipFill>
+          <a:blip r:embed="rId2"/>
+          <a:stretch>
+            <a:fillRect/>
+          </a:stretch>
+        </p:blipFill>
+        <p:spPr>
+          <a:xfrm>
+            <a:off x="9326880" y="182880"/>
+            <a:ext cx="1087459" cy="868680"/>
+          </a:xfrm>
+          <a:prstGeom prst="rect">
+            <a:avLst/>
+          </a:prstGeom>
+        </p:spPr>
+      </p:pic>
+      <p:pic>
+        <p:nvPicPr>
+          <p:cNvPr id="5" name="Picture 4" descr="logo-iiec-light.png"/>
+          <p:cNvPicPr>
+            <a:picLocks noChangeAspect="1"/>
+          </p:cNvPicPr>
+          <p:nvPr/>
+        </p:nvPicPr>
+        <p:blipFill>
+          <a:blip r:embed="rId3"/>
+          <a:stretch>
+            <a:fillRect/>
+          </a:stretch>
+        </p:blipFill>
+        <p:spPr>
+          <a:xfrm>
+            <a:off x="10698480" y="384048"/>
+            <a:ext cx="1328738" cy="502920"/>
+          </a:xfrm>
+          <a:prstGeom prst="rect">
+            <a:avLst/>
+          </a:prstGeom>
+        </p:spPr>
+      </p:pic>
+      <p:sp>
+        <p:nvSpPr>
+          <p:cNvPr id="6" name="Rectangle 5"/>
           <p:cNvSpPr/>
           <p:nvPr/>
         </p:nvSpPr>
         <p:spPr>
           <a:xfrm>
-            <a:off x="9464040" y="182880"/>
-            <a:ext cx="2514600" cy="914400"/>
-          </a:xfrm>
-          <a:prstGeom prst="roundRect">
-            <a:avLst>
-              <a:gd name="adj" fmla="val 20000"/>
-            </a:avLst>
+            <a:off x="0" y="6355080"/>
+            <a:ext cx="12191695" cy="502920"/>
+          </a:xfrm>
+          <a:prstGeom prst="rect">
+            <a:avLst/>
           </a:prstGeom>
           <a:solidFill>
-            <a:srgbClr val="000000"/>
+            <a:srgbClr val="19E3F5"/>
           </a:solidFill>
           <a:ln>
             <a:noFill/>
@@ -4561,101 +4514,9 @@
           </a:p>
         </p:txBody>
       </p:sp>
-      <p:pic>
-        <p:nvPicPr>
-          <p:cNvPr id="5" name="Picture 4" descr="logo-dsc.png"/>
-          <p:cNvPicPr>
-            <a:picLocks noChangeAspect="1"/>
-          </p:cNvPicPr>
-          <p:nvPr/>
-        </p:nvPicPr>
-        <p:blipFill>
-          <a:blip r:embed="rId2"/>
-          <a:stretch>
-            <a:fillRect/>
-          </a:stretch>
-        </p:blipFill>
-        <p:spPr>
-          <a:xfrm>
-            <a:off x="9601200" y="246888"/>
-            <a:ext cx="984436" cy="786384"/>
-          </a:xfrm>
-          <a:prstGeom prst="rect">
-            <a:avLst/>
-          </a:prstGeom>
-        </p:spPr>
-      </p:pic>
-      <p:pic>
-        <p:nvPicPr>
-          <p:cNvPr id="6" name="Picture 5" descr="logo-iiec.png"/>
-          <p:cNvPicPr>
-            <a:picLocks noChangeAspect="1"/>
-          </p:cNvPicPr>
-          <p:nvPr/>
-        </p:nvPicPr>
-        <p:blipFill>
-          <a:blip r:embed="rId3"/>
-          <a:stretch>
-            <a:fillRect/>
-          </a:stretch>
-        </p:blipFill>
-        <p:spPr>
-          <a:xfrm>
-            <a:off x="10561320" y="393192"/>
-            <a:ext cx="1328738" cy="502920"/>
-          </a:xfrm>
-          <a:prstGeom prst="rect">
-            <a:avLst/>
-          </a:prstGeom>
-        </p:spPr>
-      </p:pic>
-      <p:sp>
-        <p:nvSpPr>
-          <p:cNvPr id="7" name="Rectangle 6"/>
-          <p:cNvSpPr/>
-          <p:nvPr/>
-        </p:nvSpPr>
-        <p:spPr>
-          <a:xfrm>
-            <a:off x="0" y="6355080"/>
-            <a:ext cx="12191695" cy="502920"/>
-          </a:xfrm>
-          <a:prstGeom prst="rect">
-            <a:avLst/>
-          </a:prstGeom>
-          <a:solidFill>
-            <a:srgbClr val="19E3F5"/>
-          </a:solidFill>
-          <a:ln>
-            <a:noFill/>
-          </a:ln>
-          <a:effectLst/>
-        </p:spPr>
-        <p:style>
-          <a:lnRef idx="1">
-            <a:schemeClr val="accent1"/>
-          </a:lnRef>
-          <a:fillRef idx="3">
-            <a:schemeClr val="accent1"/>
-          </a:fillRef>
-          <a:effectRef idx="2">
-            <a:schemeClr val="accent1"/>
-          </a:effectRef>
-          <a:fontRef idx="minor">
-            <a:schemeClr val="lt1"/>
-          </a:fontRef>
-        </p:style>
-        <p:txBody>
-          <a:bodyPr rtlCol="0" anchor="ctr"/>
-          <a:lstStyle/>
-          <a:p>
-            <a:pPr algn="ctr"/>
-          </a:p>
-        </p:txBody>
-      </p:sp>
-      <p:sp>
-        <p:nvSpPr>
-          <p:cNvPr id="8" name="TextBox 7"/>
+      <p:sp>
+        <p:nvSpPr>
+          <p:cNvPr id="7" name="TextBox 6"/>
           <p:cNvSpPr txBox="1"/>
           <p:nvPr/>
         </p:nvSpPr>
@@ -4690,7 +4551,7 @@
       </p:sp>
       <p:sp>
         <p:nvSpPr>
-          <p:cNvPr id="9" name="TextBox 8"/>
+          <p:cNvPr id="8" name="TextBox 7"/>
           <p:cNvSpPr txBox="1"/>
           <p:nvPr/>
         </p:nvSpPr>
@@ -4725,7 +4586,7 @@
       </p:sp>
       <p:sp>
         <p:nvSpPr>
-          <p:cNvPr id="10" name="TextBox 9"/>
+          <p:cNvPr id="9" name="TextBox 8"/>
           <p:cNvSpPr txBox="1"/>
           <p:nvPr/>
         </p:nvSpPr>
@@ -4769,7 +4630,7 @@
       </p:sp>
       <p:sp>
         <p:nvSpPr>
-          <p:cNvPr id="11" name="TextBox 10"/>
+          <p:cNvPr id="10" name="TextBox 9"/>
           <p:cNvSpPr txBox="1"/>
           <p:nvPr/>
         </p:nvSpPr>
@@ -4958,24 +4819,70 @@
           </a:p>
         </p:txBody>
       </p:sp>
-      <p:sp>
-        <p:nvSpPr>
-          <p:cNvPr id="4" name="Rounded Rectangle 3"/>
+      <p:pic>
+        <p:nvPicPr>
+          <p:cNvPr id="4" name="Picture 3" descr="logo-dsc-light.png"/>
+          <p:cNvPicPr>
+            <a:picLocks noChangeAspect="1"/>
+          </p:cNvPicPr>
+          <p:nvPr/>
+        </p:nvPicPr>
+        <p:blipFill>
+          <a:blip r:embed="rId2"/>
+          <a:stretch>
+            <a:fillRect/>
+          </a:stretch>
+        </p:blipFill>
+        <p:spPr>
+          <a:xfrm>
+            <a:off x="9326880" y="182880"/>
+            <a:ext cx="1087459" cy="868680"/>
+          </a:xfrm>
+          <a:prstGeom prst="rect">
+            <a:avLst/>
+          </a:prstGeom>
+        </p:spPr>
+      </p:pic>
+      <p:pic>
+        <p:nvPicPr>
+          <p:cNvPr id="5" name="Picture 4" descr="logo-iiec-light.png"/>
+          <p:cNvPicPr>
+            <a:picLocks noChangeAspect="1"/>
+          </p:cNvPicPr>
+          <p:nvPr/>
+        </p:nvPicPr>
+        <p:blipFill>
+          <a:blip r:embed="rId3"/>
+          <a:stretch>
+            <a:fillRect/>
+          </a:stretch>
+        </p:blipFill>
+        <p:spPr>
+          <a:xfrm>
+            <a:off x="10698480" y="384048"/>
+            <a:ext cx="1328738" cy="502920"/>
+          </a:xfrm>
+          <a:prstGeom prst="rect">
+            <a:avLst/>
+          </a:prstGeom>
+        </p:spPr>
+      </p:pic>
+      <p:sp>
+        <p:nvSpPr>
+          <p:cNvPr id="6" name="Rectangle 5"/>
           <p:cNvSpPr/>
           <p:nvPr/>
         </p:nvSpPr>
         <p:spPr>
           <a:xfrm>
-            <a:off x="9464040" y="182880"/>
-            <a:ext cx="2514600" cy="914400"/>
-          </a:xfrm>
-          <a:prstGeom prst="roundRect">
-            <a:avLst>
-              <a:gd name="adj" fmla="val 20000"/>
-            </a:avLst>
+            <a:off x="0" y="6355080"/>
+            <a:ext cx="12191695" cy="502920"/>
+          </a:xfrm>
+          <a:prstGeom prst="rect">
+            <a:avLst/>
           </a:prstGeom>
           <a:solidFill>
-            <a:srgbClr val="000000"/>
+            <a:srgbClr val="19E3F5"/>
           </a:solidFill>
           <a:ln>
             <a:noFill/>
@@ -5004,101 +4911,9 @@
           </a:p>
         </p:txBody>
       </p:sp>
-      <p:pic>
-        <p:nvPicPr>
-          <p:cNvPr id="5" name="Picture 4" descr="logo-dsc.png"/>
-          <p:cNvPicPr>
-            <a:picLocks noChangeAspect="1"/>
-          </p:cNvPicPr>
-          <p:nvPr/>
-        </p:nvPicPr>
-        <p:blipFill>
-          <a:blip r:embed="rId2"/>
-          <a:stretch>
-            <a:fillRect/>
-          </a:stretch>
-        </p:blipFill>
-        <p:spPr>
-          <a:xfrm>
-            <a:off x="9601200" y="246888"/>
-            <a:ext cx="984436" cy="786384"/>
-          </a:xfrm>
-          <a:prstGeom prst="rect">
-            <a:avLst/>
-          </a:prstGeom>
-        </p:spPr>
-      </p:pic>
-      <p:pic>
-        <p:nvPicPr>
-          <p:cNvPr id="6" name="Picture 5" descr="logo-iiec.png"/>
-          <p:cNvPicPr>
-            <a:picLocks noChangeAspect="1"/>
-          </p:cNvPicPr>
-          <p:nvPr/>
-        </p:nvPicPr>
-        <p:blipFill>
-          <a:blip r:embed="rId3"/>
-          <a:stretch>
-            <a:fillRect/>
-          </a:stretch>
-        </p:blipFill>
-        <p:spPr>
-          <a:xfrm>
-            <a:off x="10561320" y="393192"/>
-            <a:ext cx="1328738" cy="502920"/>
-          </a:xfrm>
-          <a:prstGeom prst="rect">
-            <a:avLst/>
-          </a:prstGeom>
-        </p:spPr>
-      </p:pic>
-      <p:sp>
-        <p:nvSpPr>
-          <p:cNvPr id="7" name="Rectangle 6"/>
-          <p:cNvSpPr/>
-          <p:nvPr/>
-        </p:nvSpPr>
-        <p:spPr>
-          <a:xfrm>
-            <a:off x="0" y="6355080"/>
-            <a:ext cx="12191695" cy="502920"/>
-          </a:xfrm>
-          <a:prstGeom prst="rect">
-            <a:avLst/>
-          </a:prstGeom>
-          <a:solidFill>
-            <a:srgbClr val="19E3F5"/>
-          </a:solidFill>
-          <a:ln>
-            <a:noFill/>
-          </a:ln>
-          <a:effectLst/>
-        </p:spPr>
-        <p:style>
-          <a:lnRef idx="1">
-            <a:schemeClr val="accent1"/>
-          </a:lnRef>
-          <a:fillRef idx="3">
-            <a:schemeClr val="accent1"/>
-          </a:fillRef>
-          <a:effectRef idx="2">
-            <a:schemeClr val="accent1"/>
-          </a:effectRef>
-          <a:fontRef idx="minor">
-            <a:schemeClr val="lt1"/>
-          </a:fontRef>
-        </p:style>
-        <p:txBody>
-          <a:bodyPr rtlCol="0" anchor="ctr"/>
-          <a:lstStyle/>
-          <a:p>
-            <a:pPr algn="ctr"/>
-          </a:p>
-        </p:txBody>
-      </p:sp>
-      <p:sp>
-        <p:nvSpPr>
-          <p:cNvPr id="8" name="TextBox 7"/>
+      <p:sp>
+        <p:nvSpPr>
+          <p:cNvPr id="7" name="TextBox 6"/>
           <p:cNvSpPr txBox="1"/>
           <p:nvPr/>
         </p:nvSpPr>
@@ -5133,7 +4948,7 @@
       </p:sp>
       <p:sp>
         <p:nvSpPr>
-          <p:cNvPr id="9" name="TextBox 8"/>
+          <p:cNvPr id="8" name="TextBox 7"/>
           <p:cNvSpPr txBox="1"/>
           <p:nvPr/>
         </p:nvSpPr>
@@ -5168,7 +4983,7 @@
       </p:sp>
       <p:sp>
         <p:nvSpPr>
-          <p:cNvPr id="10" name="TextBox 9"/>
+          <p:cNvPr id="9" name="TextBox 8"/>
           <p:cNvSpPr txBox="1"/>
           <p:nvPr/>
         </p:nvSpPr>
@@ -5212,7 +5027,7 @@
       </p:sp>
       <p:sp>
         <p:nvSpPr>
-          <p:cNvPr id="11" name="TextBox 10"/>
+          <p:cNvPr id="10" name="TextBox 9"/>
           <p:cNvSpPr txBox="1"/>
           <p:nvPr/>
         </p:nvSpPr>
@@ -5401,24 +5216,70 @@
           </a:p>
         </p:txBody>
       </p:sp>
-      <p:sp>
-        <p:nvSpPr>
-          <p:cNvPr id="4" name="Rounded Rectangle 3"/>
+      <p:pic>
+        <p:nvPicPr>
+          <p:cNvPr id="4" name="Picture 3" descr="logo-dsc-light.png"/>
+          <p:cNvPicPr>
+            <a:picLocks noChangeAspect="1"/>
+          </p:cNvPicPr>
+          <p:nvPr/>
+        </p:nvPicPr>
+        <p:blipFill>
+          <a:blip r:embed="rId2"/>
+          <a:stretch>
+            <a:fillRect/>
+          </a:stretch>
+        </p:blipFill>
+        <p:spPr>
+          <a:xfrm>
+            <a:off x="9326880" y="182880"/>
+            <a:ext cx="1087459" cy="868680"/>
+          </a:xfrm>
+          <a:prstGeom prst="rect">
+            <a:avLst/>
+          </a:prstGeom>
+        </p:spPr>
+      </p:pic>
+      <p:pic>
+        <p:nvPicPr>
+          <p:cNvPr id="5" name="Picture 4" descr="logo-iiec-light.png"/>
+          <p:cNvPicPr>
+            <a:picLocks noChangeAspect="1"/>
+          </p:cNvPicPr>
+          <p:nvPr/>
+        </p:nvPicPr>
+        <p:blipFill>
+          <a:blip r:embed="rId3"/>
+          <a:stretch>
+            <a:fillRect/>
+          </a:stretch>
+        </p:blipFill>
+        <p:spPr>
+          <a:xfrm>
+            <a:off x="10698480" y="384048"/>
+            <a:ext cx="1328738" cy="502920"/>
+          </a:xfrm>
+          <a:prstGeom prst="rect">
+            <a:avLst/>
+          </a:prstGeom>
+        </p:spPr>
+      </p:pic>
+      <p:sp>
+        <p:nvSpPr>
+          <p:cNvPr id="6" name="Rectangle 5"/>
           <p:cNvSpPr/>
           <p:nvPr/>
         </p:nvSpPr>
         <p:spPr>
           <a:xfrm>
-            <a:off x="9464040" y="182880"/>
-            <a:ext cx="2514600" cy="914400"/>
-          </a:xfrm>
-          <a:prstGeom prst="roundRect">
-            <a:avLst>
-              <a:gd name="adj" fmla="val 20000"/>
-            </a:avLst>
+            <a:off x="0" y="6355080"/>
+            <a:ext cx="12191695" cy="502920"/>
+          </a:xfrm>
+          <a:prstGeom prst="rect">
+            <a:avLst/>
           </a:prstGeom>
           <a:solidFill>
-            <a:srgbClr val="000000"/>
+            <a:srgbClr val="19E3F5"/>
           </a:solidFill>
           <a:ln>
             <a:noFill/>
@@ -5447,101 +5308,9 @@
           </a:p>
         </p:txBody>
       </p:sp>
-      <p:pic>
-        <p:nvPicPr>
-          <p:cNvPr id="5" name="Picture 4" descr="logo-dsc.png"/>
-          <p:cNvPicPr>
-            <a:picLocks noChangeAspect="1"/>
-          </p:cNvPicPr>
-          <p:nvPr/>
-        </p:nvPicPr>
-        <p:blipFill>
-          <a:blip r:embed="rId2"/>
-          <a:stretch>
-            <a:fillRect/>
-          </a:stretch>
-        </p:blipFill>
-        <p:spPr>
-          <a:xfrm>
-            <a:off x="9601200" y="246888"/>
-            <a:ext cx="984436" cy="786384"/>
-          </a:xfrm>
-          <a:prstGeom prst="rect">
-            <a:avLst/>
-          </a:prstGeom>
-        </p:spPr>
-      </p:pic>
-      <p:pic>
-        <p:nvPicPr>
-          <p:cNvPr id="6" name="Picture 5" descr="logo-iiec.png"/>
-          <p:cNvPicPr>
-            <a:picLocks noChangeAspect="1"/>
-          </p:cNvPicPr>
-          <p:nvPr/>
-        </p:nvPicPr>
-        <p:blipFill>
-          <a:blip r:embed="rId3"/>
-          <a:stretch>
-            <a:fillRect/>
-          </a:stretch>
-        </p:blipFill>
-        <p:spPr>
-          <a:xfrm>
-            <a:off x="10561320" y="393192"/>
-            <a:ext cx="1328738" cy="502920"/>
-          </a:xfrm>
-          <a:prstGeom prst="rect">
-            <a:avLst/>
-          </a:prstGeom>
-        </p:spPr>
-      </p:pic>
-      <p:sp>
-        <p:nvSpPr>
-          <p:cNvPr id="7" name="Rectangle 6"/>
-          <p:cNvSpPr/>
-          <p:nvPr/>
-        </p:nvSpPr>
-        <p:spPr>
-          <a:xfrm>
-            <a:off x="0" y="6355080"/>
-            <a:ext cx="12191695" cy="502920"/>
-          </a:xfrm>
-          <a:prstGeom prst="rect">
-            <a:avLst/>
-          </a:prstGeom>
-          <a:solidFill>
-            <a:srgbClr val="19E3F5"/>
-          </a:solidFill>
-          <a:ln>
-            <a:noFill/>
-          </a:ln>
-          <a:effectLst/>
-        </p:spPr>
-        <p:style>
-          <a:lnRef idx="1">
-            <a:schemeClr val="accent1"/>
-          </a:lnRef>
-          <a:fillRef idx="3">
-            <a:schemeClr val="accent1"/>
-          </a:fillRef>
-          <a:effectRef idx="2">
-            <a:schemeClr val="accent1"/>
-          </a:effectRef>
-          <a:fontRef idx="minor">
-            <a:schemeClr val="lt1"/>
-          </a:fontRef>
-        </p:style>
-        <p:txBody>
-          <a:bodyPr rtlCol="0" anchor="ctr"/>
-          <a:lstStyle/>
-          <a:p>
-            <a:pPr algn="ctr"/>
-          </a:p>
-        </p:txBody>
-      </p:sp>
-      <p:sp>
-        <p:nvSpPr>
-          <p:cNvPr id="8" name="TextBox 7"/>
+      <p:sp>
+        <p:nvSpPr>
+          <p:cNvPr id="7" name="TextBox 6"/>
           <p:cNvSpPr txBox="1"/>
           <p:nvPr/>
         </p:nvSpPr>
@@ -5576,7 +5345,7 @@
       </p:sp>
       <p:sp>
         <p:nvSpPr>
-          <p:cNvPr id="9" name="TextBox 8"/>
+          <p:cNvPr id="8" name="TextBox 7"/>
           <p:cNvSpPr txBox="1"/>
           <p:nvPr/>
         </p:nvSpPr>
@@ -5611,7 +5380,7 @@
       </p:sp>
       <p:sp>
         <p:nvSpPr>
-          <p:cNvPr id="10" name="TextBox 9"/>
+          <p:cNvPr id="9" name="TextBox 8"/>
           <p:cNvSpPr txBox="1"/>
           <p:nvPr/>
         </p:nvSpPr>
@@ -5655,7 +5424,7 @@
       </p:sp>
       <p:sp>
         <p:nvSpPr>
-          <p:cNvPr id="11" name="TextBox 10"/>
+          <p:cNvPr id="10" name="TextBox 9"/>
           <p:cNvSpPr txBox="1"/>
           <p:nvPr/>
         </p:nvSpPr>
@@ -5696,7 +5465,7 @@
       </p:sp>
       <p:sp>
         <p:nvSpPr>
-          <p:cNvPr id="12" name="TextBox 11"/>
+          <p:cNvPr id="11" name="TextBox 10"/>
           <p:cNvSpPr txBox="1"/>
           <p:nvPr/>
         </p:nvSpPr>
@@ -5749,7 +5518,7 @@
       </p:sp>
       <p:sp>
         <p:nvSpPr>
-          <p:cNvPr id="13" name="TextBox 12"/>
+          <p:cNvPr id="12" name="TextBox 11"/>
           <p:cNvSpPr txBox="1"/>
           <p:nvPr/>
         </p:nvSpPr>
@@ -5920,24 +5689,70 @@
           </a:p>
         </p:txBody>
       </p:sp>
-      <p:sp>
-        <p:nvSpPr>
-          <p:cNvPr id="4" name="Rounded Rectangle 3"/>
+      <p:pic>
+        <p:nvPicPr>
+          <p:cNvPr id="4" name="Picture 3" descr="logo-dsc-light.png"/>
+          <p:cNvPicPr>
+            <a:picLocks noChangeAspect="1"/>
+          </p:cNvPicPr>
+          <p:nvPr/>
+        </p:nvPicPr>
+        <p:blipFill>
+          <a:blip r:embed="rId2"/>
+          <a:stretch>
+            <a:fillRect/>
+          </a:stretch>
+        </p:blipFill>
+        <p:spPr>
+          <a:xfrm>
+            <a:off x="9326880" y="182880"/>
+            <a:ext cx="1087459" cy="868680"/>
+          </a:xfrm>
+          <a:prstGeom prst="rect">
+            <a:avLst/>
+          </a:prstGeom>
+        </p:spPr>
+      </p:pic>
+      <p:pic>
+        <p:nvPicPr>
+          <p:cNvPr id="5" name="Picture 4" descr="logo-iiec-light.png"/>
+          <p:cNvPicPr>
+            <a:picLocks noChangeAspect="1"/>
+          </p:cNvPicPr>
+          <p:nvPr/>
+        </p:nvPicPr>
+        <p:blipFill>
+          <a:blip r:embed="rId3"/>
+          <a:stretch>
+            <a:fillRect/>
+          </a:stretch>
+        </p:blipFill>
+        <p:spPr>
+          <a:xfrm>
+            <a:off x="10698480" y="384048"/>
+            <a:ext cx="1328738" cy="502920"/>
+          </a:xfrm>
+          <a:prstGeom prst="rect">
+            <a:avLst/>
+          </a:prstGeom>
+        </p:spPr>
+      </p:pic>
+      <p:sp>
+        <p:nvSpPr>
+          <p:cNvPr id="6" name="Rectangle 5"/>
           <p:cNvSpPr/>
           <p:nvPr/>
         </p:nvSpPr>
         <p:spPr>
           <a:xfrm>
-            <a:off x="9464040" y="182880"/>
-            <a:ext cx="2514600" cy="914400"/>
-          </a:xfrm>
-          <a:prstGeom prst="roundRect">
-            <a:avLst>
-              <a:gd name="adj" fmla="val 20000"/>
-            </a:avLst>
+            <a:off x="0" y="6355080"/>
+            <a:ext cx="12191695" cy="502920"/>
+          </a:xfrm>
+          <a:prstGeom prst="rect">
+            <a:avLst/>
           </a:prstGeom>
           <a:solidFill>
-            <a:srgbClr val="000000"/>
+            <a:srgbClr val="19E3F5"/>
           </a:solidFill>
           <a:ln>
             <a:noFill/>
@@ -5966,101 +5781,9 @@
           </a:p>
         </p:txBody>
       </p:sp>
-      <p:pic>
-        <p:nvPicPr>
-          <p:cNvPr id="5" name="Picture 4" descr="logo-dsc.png"/>
-          <p:cNvPicPr>
-            <a:picLocks noChangeAspect="1"/>
-          </p:cNvPicPr>
-          <p:nvPr/>
-        </p:nvPicPr>
-        <p:blipFill>
-          <a:blip r:embed="rId2"/>
-          <a:stretch>
-            <a:fillRect/>
-          </a:stretch>
-        </p:blipFill>
-        <p:spPr>
-          <a:xfrm>
-            <a:off x="9601200" y="246888"/>
-            <a:ext cx="984436" cy="786384"/>
-          </a:xfrm>
-          <a:prstGeom prst="rect">
-            <a:avLst/>
-          </a:prstGeom>
-        </p:spPr>
-      </p:pic>
-      <p:pic>
-        <p:nvPicPr>
-          <p:cNvPr id="6" name="Picture 5" descr="logo-iiec.png"/>
-          <p:cNvPicPr>
-            <a:picLocks noChangeAspect="1"/>
-          </p:cNvPicPr>
-          <p:nvPr/>
-        </p:nvPicPr>
-        <p:blipFill>
-          <a:blip r:embed="rId3"/>
-          <a:stretch>
-            <a:fillRect/>
-          </a:stretch>
-        </p:blipFill>
-        <p:spPr>
-          <a:xfrm>
-            <a:off x="10561320" y="393192"/>
-            <a:ext cx="1328738" cy="502920"/>
-          </a:xfrm>
-          <a:prstGeom prst="rect">
-            <a:avLst/>
-          </a:prstGeom>
-        </p:spPr>
-      </p:pic>
-      <p:sp>
-        <p:nvSpPr>
-          <p:cNvPr id="7" name="Rectangle 6"/>
-          <p:cNvSpPr/>
-          <p:nvPr/>
-        </p:nvSpPr>
-        <p:spPr>
-          <a:xfrm>
-            <a:off x="0" y="6355080"/>
-            <a:ext cx="12191695" cy="502920"/>
-          </a:xfrm>
-          <a:prstGeom prst="rect">
-            <a:avLst/>
-          </a:prstGeom>
-          <a:solidFill>
-            <a:srgbClr val="19E3F5"/>
-          </a:solidFill>
-          <a:ln>
-            <a:noFill/>
-          </a:ln>
-          <a:effectLst/>
-        </p:spPr>
-        <p:style>
-          <a:lnRef idx="1">
-            <a:schemeClr val="accent1"/>
-          </a:lnRef>
-          <a:fillRef idx="3">
-            <a:schemeClr val="accent1"/>
-          </a:fillRef>
-          <a:effectRef idx="2">
-            <a:schemeClr val="accent1"/>
-          </a:effectRef>
-          <a:fontRef idx="minor">
-            <a:schemeClr val="lt1"/>
-          </a:fontRef>
-        </p:style>
-        <p:txBody>
-          <a:bodyPr rtlCol="0" anchor="ctr"/>
-          <a:lstStyle/>
-          <a:p>
-            <a:pPr algn="ctr"/>
-          </a:p>
-        </p:txBody>
-      </p:sp>
-      <p:sp>
-        <p:nvSpPr>
-          <p:cNvPr id="8" name="TextBox 7"/>
+      <p:sp>
+        <p:nvSpPr>
+          <p:cNvPr id="7" name="TextBox 6"/>
           <p:cNvSpPr txBox="1"/>
           <p:nvPr/>
         </p:nvSpPr>
@@ -6095,7 +5818,7 @@
       </p:sp>
       <p:sp>
         <p:nvSpPr>
-          <p:cNvPr id="9" name="TextBox 8"/>
+          <p:cNvPr id="8" name="TextBox 7"/>
           <p:cNvSpPr txBox="1"/>
           <p:nvPr/>
         </p:nvSpPr>
@@ -6130,7 +5853,7 @@
       </p:sp>
       <p:sp>
         <p:nvSpPr>
-          <p:cNvPr id="10" name="TextBox 9"/>
+          <p:cNvPr id="9" name="TextBox 8"/>
           <p:cNvSpPr txBox="1"/>
           <p:nvPr/>
         </p:nvSpPr>
@@ -6174,7 +5897,7 @@
       </p:sp>
       <p:sp>
         <p:nvSpPr>
-          <p:cNvPr id="11" name="TextBox 10"/>
+          <p:cNvPr id="10" name="TextBox 9"/>
           <p:cNvSpPr txBox="1"/>
           <p:nvPr/>
         </p:nvSpPr>
@@ -6345,24 +6068,70 @@
           </a:p>
         </p:txBody>
       </p:sp>
-      <p:sp>
-        <p:nvSpPr>
-          <p:cNvPr id="4" name="Rounded Rectangle 3"/>
+      <p:pic>
+        <p:nvPicPr>
+          <p:cNvPr id="4" name="Picture 3" descr="logo-dsc-light.png"/>
+          <p:cNvPicPr>
+            <a:picLocks noChangeAspect="1"/>
+          </p:cNvPicPr>
+          <p:nvPr/>
+        </p:nvPicPr>
+        <p:blipFill>
+          <a:blip r:embed="rId2"/>
+          <a:stretch>
+            <a:fillRect/>
+          </a:stretch>
+        </p:blipFill>
+        <p:spPr>
+          <a:xfrm>
+            <a:off x="9326880" y="182880"/>
+            <a:ext cx="1087459" cy="868680"/>
+          </a:xfrm>
+          <a:prstGeom prst="rect">
+            <a:avLst/>
+          </a:prstGeom>
+        </p:spPr>
+      </p:pic>
+      <p:pic>
+        <p:nvPicPr>
+          <p:cNvPr id="5" name="Picture 4" descr="logo-iiec-light.png"/>
+          <p:cNvPicPr>
+            <a:picLocks noChangeAspect="1"/>
+          </p:cNvPicPr>
+          <p:nvPr/>
+        </p:nvPicPr>
+        <p:blipFill>
+          <a:blip r:embed="rId3"/>
+          <a:stretch>
+            <a:fillRect/>
+          </a:stretch>
+        </p:blipFill>
+        <p:spPr>
+          <a:xfrm>
+            <a:off x="10698480" y="384048"/>
+            <a:ext cx="1328738" cy="502920"/>
+          </a:xfrm>
+          <a:prstGeom prst="rect">
+            <a:avLst/>
+          </a:prstGeom>
+        </p:spPr>
+      </p:pic>
+      <p:sp>
+        <p:nvSpPr>
+          <p:cNvPr id="6" name="Rectangle 5"/>
           <p:cNvSpPr/>
           <p:nvPr/>
         </p:nvSpPr>
         <p:spPr>
           <a:xfrm>
-            <a:off x="9464040" y="182880"/>
-            <a:ext cx="2514600" cy="914400"/>
-          </a:xfrm>
-          <a:prstGeom prst="roundRect">
-            <a:avLst>
-              <a:gd name="adj" fmla="val 20000"/>
-            </a:avLst>
+            <a:off x="0" y="6355080"/>
+            <a:ext cx="12191695" cy="502920"/>
+          </a:xfrm>
+          <a:prstGeom prst="rect">
+            <a:avLst/>
           </a:prstGeom>
           <a:solidFill>
-            <a:srgbClr val="000000"/>
+            <a:srgbClr val="19E3F5"/>
           </a:solidFill>
           <a:ln>
             <a:noFill/>
@@ -6391,101 +6160,9 @@
           </a:p>
         </p:txBody>
       </p:sp>
-      <p:pic>
-        <p:nvPicPr>
-          <p:cNvPr id="5" name="Picture 4" descr="logo-dsc.png"/>
-          <p:cNvPicPr>
-            <a:picLocks noChangeAspect="1"/>
-          </p:cNvPicPr>
-          <p:nvPr/>
-        </p:nvPicPr>
-        <p:blipFill>
-          <a:blip r:embed="rId2"/>
-          <a:stretch>
-            <a:fillRect/>
-          </a:stretch>
-        </p:blipFill>
-        <p:spPr>
-          <a:xfrm>
-            <a:off x="9601200" y="246888"/>
-            <a:ext cx="984436" cy="786384"/>
-          </a:xfrm>
-          <a:prstGeom prst="rect">
-            <a:avLst/>
-          </a:prstGeom>
-        </p:spPr>
-      </p:pic>
-      <p:pic>
-        <p:nvPicPr>
-          <p:cNvPr id="6" name="Picture 5" descr="logo-iiec.png"/>
-          <p:cNvPicPr>
-            <a:picLocks noChangeAspect="1"/>
-          </p:cNvPicPr>
-          <p:nvPr/>
-        </p:nvPicPr>
-        <p:blipFill>
-          <a:blip r:embed="rId3"/>
-          <a:stretch>
-            <a:fillRect/>
-          </a:stretch>
-        </p:blipFill>
-        <p:spPr>
-          <a:xfrm>
-            <a:off x="10561320" y="393192"/>
-            <a:ext cx="1328738" cy="502920"/>
-          </a:xfrm>
-          <a:prstGeom prst="rect">
-            <a:avLst/>
-          </a:prstGeom>
-        </p:spPr>
-      </p:pic>
-      <p:sp>
-        <p:nvSpPr>
-          <p:cNvPr id="7" name="Rectangle 6"/>
-          <p:cNvSpPr/>
-          <p:nvPr/>
-        </p:nvSpPr>
-        <p:spPr>
-          <a:xfrm>
-            <a:off x="0" y="6355080"/>
-            <a:ext cx="12191695" cy="502920"/>
-          </a:xfrm>
-          <a:prstGeom prst="rect">
-            <a:avLst/>
-          </a:prstGeom>
-          <a:solidFill>
-            <a:srgbClr val="19E3F5"/>
-          </a:solidFill>
-          <a:ln>
-            <a:noFill/>
-          </a:ln>
-          <a:effectLst/>
-        </p:spPr>
-        <p:style>
-          <a:lnRef idx="1">
-            <a:schemeClr val="accent1"/>
-          </a:lnRef>
-          <a:fillRef idx="3">
-            <a:schemeClr val="accent1"/>
-          </a:fillRef>
-          <a:effectRef idx="2">
-            <a:schemeClr val="accent1"/>
-          </a:effectRef>
-          <a:fontRef idx="minor">
-            <a:schemeClr val="lt1"/>
-          </a:fontRef>
-        </p:style>
-        <p:txBody>
-          <a:bodyPr rtlCol="0" anchor="ctr"/>
-          <a:lstStyle/>
-          <a:p>
-            <a:pPr algn="ctr"/>
-          </a:p>
-        </p:txBody>
-      </p:sp>
-      <p:sp>
-        <p:nvSpPr>
-          <p:cNvPr id="8" name="TextBox 7"/>
+      <p:sp>
+        <p:nvSpPr>
+          <p:cNvPr id="7" name="TextBox 6"/>
           <p:cNvSpPr txBox="1"/>
           <p:nvPr/>
         </p:nvSpPr>
@@ -6520,7 +6197,7 @@
       </p:sp>
       <p:sp>
         <p:nvSpPr>
-          <p:cNvPr id="9" name="TextBox 8"/>
+          <p:cNvPr id="8" name="TextBox 7"/>
           <p:cNvSpPr txBox="1"/>
           <p:nvPr/>
         </p:nvSpPr>
@@ -6555,7 +6232,7 @@
       </p:sp>
       <p:sp>
         <p:nvSpPr>
-          <p:cNvPr id="10" name="TextBox 9"/>
+          <p:cNvPr id="9" name="TextBox 8"/>
           <p:cNvSpPr txBox="1"/>
           <p:nvPr/>
         </p:nvSpPr>
@@ -6599,7 +6276,7 @@
       </p:sp>
       <p:sp>
         <p:nvSpPr>
-          <p:cNvPr id="11" name="TextBox 10"/>
+          <p:cNvPr id="10" name="TextBox 9"/>
           <p:cNvSpPr txBox="1"/>
           <p:nvPr/>
         </p:nvSpPr>
@@ -6670,565 +6347,6 @@
                 <a:latin typeface="Arial"/>
               </a:rPr>
               <a:t>Next steps and references</a:t>
-            </a:r>
-          </a:p>
-        </p:txBody>
-      </p:sp>
-    </p:spTree>
-  </p:cSld>
-  <p:clrMapOvr>
-    <a:masterClrMapping/>
-  </p:clrMapOvr>
-</p:sld>
-</file>
-
-<file path=ppt/slides/slide9.xml><?xml version="1.0" encoding="utf-8"?>
-<p:sld xmlns:a="http://schemas.openxmlformats.org/drawingml/2006/main" xmlns:p="http://schemas.openxmlformats.org/presentationml/2006/main" xmlns:r="http://schemas.openxmlformats.org/officeDocument/2006/relationships">
-  <p:cSld>
-    <p:bg>
-      <p:bgPr>
-        <a:solidFill>
-          <a:srgbClr val="FFFFFF"/>
-        </a:solidFill>
-        <a:effectLst/>
-      </p:bgPr>
-    </p:bg>
-    <p:spTree>
-      <p:nvGrpSpPr>
-        <p:cNvPr id="1" name=""/>
-        <p:cNvGrpSpPr/>
-        <p:nvPr/>
-      </p:nvGrpSpPr>
-      <p:grpSpPr/>
-      <p:sp>
-        <p:nvSpPr>
-          <p:cNvPr id="2" name="Oval 1"/>
-          <p:cNvSpPr/>
-          <p:nvPr/>
-        </p:nvSpPr>
-        <p:spPr>
-          <a:xfrm>
-            <a:off x="365760" y="274320"/>
-            <a:ext cx="1463040" cy="777240"/>
-          </a:xfrm>
-          <a:prstGeom prst="ellipse">
-            <a:avLst/>
-          </a:prstGeom>
-          <a:noFill/>
-          <a:ln w="31750">
-            <a:solidFill>
-              <a:srgbClr val="19E3F5"/>
-            </a:solidFill>
-          </a:ln>
-          <a:effectLst/>
-        </p:spPr>
-        <p:style>
-          <a:lnRef idx="1">
-            <a:schemeClr val="accent1"/>
-          </a:lnRef>
-          <a:fillRef idx="3">
-            <a:schemeClr val="accent1"/>
-          </a:fillRef>
-          <a:effectRef idx="2">
-            <a:schemeClr val="accent1"/>
-          </a:effectRef>
-          <a:fontRef idx="minor">
-            <a:schemeClr val="lt1"/>
-          </a:fontRef>
-        </p:style>
-        <p:txBody>
-          <a:bodyPr rtlCol="0" anchor="ctr" wrap="square"/>
-          <a:lstStyle/>
-          <a:p>
-            <a:pPr algn="ctr"/>
-            <a:r>
-              <a:rPr sz="1200" b="0">
-                <a:solidFill>
-                  <a:srgbClr val="000000"/>
-                </a:solidFill>
-                <a:latin typeface="Arial"/>
-              </a:rPr>
-              <a:t>Your Team Name</a:t>
-            </a:r>
-          </a:p>
-        </p:txBody>
-      </p:sp>
-      <p:sp>
-        <p:nvSpPr>
-          <p:cNvPr id="3" name="TextBox 2"/>
-          <p:cNvSpPr txBox="1"/>
-          <p:nvPr/>
-        </p:nvSpPr>
-        <p:spPr>
-          <a:xfrm>
-            <a:off x="1920240" y="228600"/>
-            <a:ext cx="7406640" cy="868680"/>
-          </a:xfrm>
-          <a:prstGeom prst="rect">
-            <a:avLst/>
-          </a:prstGeom>
-          <a:noFill/>
-        </p:spPr>
-        <p:txBody>
-          <a:bodyPr wrap="square" anchor="ctr">
-            <a:spAutoFit/>
-          </a:bodyPr>
-          <a:lstStyle/>
-          <a:p>
-            <a:pPr algn="ctr"/>
-            <a:r>
-              <a:rPr sz="3000" b="0">
-                <a:solidFill>
-                  <a:srgbClr val="000000"/>
-                </a:solidFill>
-                <a:latin typeface="Arial Black"/>
-              </a:rPr>
-              <a:t>IMPORTANT INSTRUCTIONS</a:t>
-            </a:r>
-          </a:p>
-        </p:txBody>
-      </p:sp>
-      <p:sp>
-        <p:nvSpPr>
-          <p:cNvPr id="4" name="Rounded Rectangle 3"/>
-          <p:cNvSpPr/>
-          <p:nvPr/>
-        </p:nvSpPr>
-        <p:spPr>
-          <a:xfrm>
-            <a:off x="9464040" y="182880"/>
-            <a:ext cx="2514600" cy="914400"/>
-          </a:xfrm>
-          <a:prstGeom prst="roundRect">
-            <a:avLst>
-              <a:gd name="adj" fmla="val 20000"/>
-            </a:avLst>
-          </a:prstGeom>
-          <a:solidFill>
-            <a:srgbClr val="000000"/>
-          </a:solidFill>
-          <a:ln>
-            <a:noFill/>
-          </a:ln>
-          <a:effectLst/>
-        </p:spPr>
-        <p:style>
-          <a:lnRef idx="1">
-            <a:schemeClr val="accent1"/>
-          </a:lnRef>
-          <a:fillRef idx="3">
-            <a:schemeClr val="accent1"/>
-          </a:fillRef>
-          <a:effectRef idx="2">
-            <a:schemeClr val="accent1"/>
-          </a:effectRef>
-          <a:fontRef idx="minor">
-            <a:schemeClr val="lt1"/>
-          </a:fontRef>
-        </p:style>
-        <p:txBody>
-          <a:bodyPr rtlCol="0" anchor="ctr"/>
-          <a:lstStyle/>
-          <a:p>
-            <a:pPr algn="ctr"/>
-          </a:p>
-        </p:txBody>
-      </p:sp>
-      <p:pic>
-        <p:nvPicPr>
-          <p:cNvPr id="5" name="Picture 4" descr="logo-dsc.png"/>
-          <p:cNvPicPr>
-            <a:picLocks noChangeAspect="1"/>
-          </p:cNvPicPr>
-          <p:nvPr/>
-        </p:nvPicPr>
-        <p:blipFill>
-          <a:blip r:embed="rId2"/>
-          <a:stretch>
-            <a:fillRect/>
-          </a:stretch>
-        </p:blipFill>
-        <p:spPr>
-          <a:xfrm>
-            <a:off x="9601200" y="246888"/>
-            <a:ext cx="984436" cy="786384"/>
-          </a:xfrm>
-          <a:prstGeom prst="rect">
-            <a:avLst/>
-          </a:prstGeom>
-        </p:spPr>
-      </p:pic>
-      <p:pic>
-        <p:nvPicPr>
-          <p:cNvPr id="6" name="Picture 5" descr="logo-iiec.png"/>
-          <p:cNvPicPr>
-            <a:picLocks noChangeAspect="1"/>
-          </p:cNvPicPr>
-          <p:nvPr/>
-        </p:nvPicPr>
-        <p:blipFill>
-          <a:blip r:embed="rId3"/>
-          <a:stretch>
-            <a:fillRect/>
-          </a:stretch>
-        </p:blipFill>
-        <p:spPr>
-          <a:xfrm>
-            <a:off x="10561320" y="393192"/>
-            <a:ext cx="1328738" cy="502920"/>
-          </a:xfrm>
-          <a:prstGeom prst="rect">
-            <a:avLst/>
-          </a:prstGeom>
-        </p:spPr>
-      </p:pic>
-      <p:sp>
-        <p:nvSpPr>
-          <p:cNvPr id="7" name="Rectangle 6"/>
-          <p:cNvSpPr/>
-          <p:nvPr/>
-        </p:nvSpPr>
-        <p:spPr>
-          <a:xfrm>
-            <a:off x="0" y="6355080"/>
-            <a:ext cx="12191695" cy="502920"/>
-          </a:xfrm>
-          <a:prstGeom prst="rect">
-            <a:avLst/>
-          </a:prstGeom>
-          <a:solidFill>
-            <a:srgbClr val="19E3F5"/>
-          </a:solidFill>
-          <a:ln>
-            <a:noFill/>
-          </a:ln>
-          <a:effectLst/>
-        </p:spPr>
-        <p:style>
-          <a:lnRef idx="1">
-            <a:schemeClr val="accent1"/>
-          </a:lnRef>
-          <a:fillRef idx="3">
-            <a:schemeClr val="accent1"/>
-          </a:fillRef>
-          <a:effectRef idx="2">
-            <a:schemeClr val="accent1"/>
-          </a:effectRef>
-          <a:fontRef idx="minor">
-            <a:schemeClr val="lt1"/>
-          </a:fontRef>
-        </p:style>
-        <p:txBody>
-          <a:bodyPr rtlCol="0" anchor="ctr"/>
-          <a:lstStyle/>
-          <a:p>
-            <a:pPr algn="ctr"/>
-          </a:p>
-        </p:txBody>
-      </p:sp>
-      <p:sp>
-        <p:nvSpPr>
-          <p:cNvPr id="8" name="TextBox 7"/>
-          <p:cNvSpPr txBox="1"/>
-          <p:nvPr/>
-        </p:nvSpPr>
-        <p:spPr>
-          <a:xfrm>
-            <a:off x="0" y="6355080"/>
-            <a:ext cx="12191695" cy="502920"/>
-          </a:xfrm>
-          <a:prstGeom prst="rect">
-            <a:avLst/>
-          </a:prstGeom>
-          <a:noFill/>
-        </p:spPr>
-        <p:txBody>
-          <a:bodyPr wrap="square" anchor="ctr">
-            <a:spAutoFit/>
-          </a:bodyPr>
-          <a:lstStyle/>
-          <a:p>
-            <a:pPr algn="ctr"/>
-            <a:r>
-              <a:rPr sz="1200" b="1">
-                <a:solidFill>
-                  <a:srgbClr val="000000"/>
-                </a:solidFill>
-                <a:latin typeface="Arial"/>
-              </a:rPr>
-              <a:t>DATATHON 2026  ·  Round 1 Idea Submission – Template</a:t>
-            </a:r>
-          </a:p>
-        </p:txBody>
-      </p:sp>
-      <p:sp>
-        <p:nvSpPr>
-          <p:cNvPr id="9" name="TextBox 8"/>
-          <p:cNvSpPr txBox="1"/>
-          <p:nvPr/>
-        </p:nvSpPr>
-        <p:spPr>
-          <a:xfrm>
-            <a:off x="10881360" y="6355080"/>
-            <a:ext cx="1005840" cy="502920"/>
-          </a:xfrm>
-          <a:prstGeom prst="rect">
-            <a:avLst/>
-          </a:prstGeom>
-          <a:noFill/>
-        </p:spPr>
-        <p:txBody>
-          <a:bodyPr wrap="square" anchor="ctr">
-            <a:spAutoFit/>
-          </a:bodyPr>
-          <a:lstStyle/>
-          <a:p>
-            <a:pPr algn="r"/>
-            <a:r>
-              <a:rPr sz="1300" b="1">
-                <a:solidFill>
-                  <a:srgbClr val="000000"/>
-                </a:solidFill>
-                <a:latin typeface="Arial"/>
-              </a:rPr>
-              <a:t>9</a:t>
-            </a:r>
-          </a:p>
-        </p:txBody>
-      </p:sp>
-      <p:sp>
-        <p:nvSpPr>
-          <p:cNvPr id="10" name="TextBox 9"/>
-          <p:cNvSpPr txBox="1"/>
-          <p:nvPr/>
-        </p:nvSpPr>
-        <p:spPr>
-          <a:xfrm>
-            <a:off x="548640" y="1280160"/>
-            <a:ext cx="10972800" cy="457200"/>
-          </a:xfrm>
-          <a:prstGeom prst="rect">
-            <a:avLst/>
-          </a:prstGeom>
-          <a:noFill/>
-        </p:spPr>
-        <p:txBody>
-          <a:bodyPr wrap="square" anchor="t">
-            <a:spAutoFit/>
-          </a:bodyPr>
-          <a:lstStyle/>
-          <a:p>
-            <a:pPr algn="l"/>
-            <a:r>
-              <a:rPr sz="1800" b="1">
-                <a:solidFill>
-                  <a:srgbClr val="000000"/>
-                </a:solidFill>
-                <a:latin typeface="Arial"/>
-              </a:rPr>
-              <a:t>Please ensure the pointers below are met while submitting the Round 1 Idea PPT:</a:t>
-            </a:r>
-          </a:p>
-        </p:txBody>
-      </p:sp>
-      <p:sp>
-        <p:nvSpPr>
-          <p:cNvPr id="11" name="Rounded Rectangle 10"/>
-          <p:cNvSpPr/>
-          <p:nvPr/>
-        </p:nvSpPr>
-        <p:spPr>
-          <a:xfrm>
-            <a:off x="365760" y="1874519"/>
-            <a:ext cx="11430000" cy="4114800"/>
-          </a:xfrm>
-          <a:prstGeom prst="roundRect">
-            <a:avLst>
-              <a:gd name="adj" fmla="val 6000"/>
-            </a:avLst>
-          </a:prstGeom>
-          <a:solidFill>
-            <a:srgbClr val="DFFBFE"/>
-          </a:solidFill>
-          <a:ln w="19050">
-            <a:solidFill>
-              <a:srgbClr val="000000"/>
-            </a:solidFill>
-          </a:ln>
-          <a:effectLst/>
-        </p:spPr>
-        <p:style>
-          <a:lnRef idx="1">
-            <a:schemeClr val="accent1"/>
-          </a:lnRef>
-          <a:fillRef idx="3">
-            <a:schemeClr val="accent1"/>
-          </a:fillRef>
-          <a:effectRef idx="2">
-            <a:schemeClr val="accent1"/>
-          </a:effectRef>
-          <a:fontRef idx="minor">
-            <a:schemeClr val="lt1"/>
-          </a:fontRef>
-        </p:style>
-        <p:txBody>
-          <a:bodyPr rtlCol="0" anchor="ctr"/>
-          <a:lstStyle/>
-          <a:p>
-            <a:pPr algn="ctr"/>
-          </a:p>
-        </p:txBody>
-      </p:sp>
-      <p:sp>
-        <p:nvSpPr>
-          <p:cNvPr id="12" name="TextBox 11"/>
-          <p:cNvSpPr txBox="1"/>
-          <p:nvPr/>
-        </p:nvSpPr>
-        <p:spPr>
-          <a:xfrm>
-            <a:off x="731520" y="2057400"/>
-            <a:ext cx="10789920" cy="3108960"/>
-          </a:xfrm>
-          <a:prstGeom prst="rect">
-            <a:avLst/>
-          </a:prstGeom>
-          <a:noFill/>
-        </p:spPr>
-        <p:txBody>
-          <a:bodyPr wrap="square">
-            <a:spAutoFit/>
-          </a:bodyPr>
-          <a:lstStyle/>
-          <a:p>
-            <a:pPr>
-              <a:spcAft>
-                <a:spcPts val="800"/>
-              </a:spcAft>
-            </a:pPr>
-            <a:r>
-              <a:rPr b="1" sz="1800">
-                <a:solidFill>
-                  <a:srgbClr val="000000"/>
-                </a:solidFill>
-                <a:latin typeface="Arial"/>
-              </a:rPr>
-              <a:t>1.  Maximum eight (8) slides, including the title slide.</a:t>
-            </a:r>
-          </a:p>
-          <a:p>
-            <a:pPr>
-              <a:spcAft>
-                <a:spcPts val="800"/>
-              </a:spcAft>
-            </a:pPr>
-            <a:r>
-              <a:rPr b="1" sz="1800">
-                <a:solidFill>
-                  <a:srgbClr val="000000"/>
-                </a:solidFill>
-                <a:latin typeface="Arial"/>
-              </a:rPr>
-              <a:t>2.  USP and MVP sections are mandatory.</a:t>
-            </a:r>
-          </a:p>
-          <a:p>
-            <a:pPr>
-              <a:spcAft>
-                <a:spcPts val="800"/>
-              </a:spcAft>
-            </a:pPr>
-            <a:r>
-              <a:rPr b="1" sz="1800">
-                <a:solidFill>
-                  <a:srgbClr val="000000"/>
-                </a:solidFill>
-                <a:latin typeface="Arial"/>
-              </a:rPr>
-              <a:t>3.  Avoid paragraphs. Use points, diagrams and screenshots.</a:t>
-            </a:r>
-          </a:p>
-          <a:p>
-            <a:pPr>
-              <a:spcAft>
-                <a:spcPts val="800"/>
-              </a:spcAft>
-            </a:pPr>
-            <a:r>
-              <a:rPr b="1" sz="1800">
-                <a:solidFill>
-                  <a:srgbClr val="000000"/>
-                </a:solidFill>
-                <a:latin typeface="Arial"/>
-              </a:rPr>
-              <a:t>4.  Keep the headings as they are and fill in your own details.</a:t>
-            </a:r>
-          </a:p>
-          <a:p>
-            <a:pPr>
-              <a:spcAft>
-                <a:spcPts val="800"/>
-              </a:spcAft>
-            </a:pPr>
-            <a:r>
-              <a:rPr b="1" sz="1800">
-                <a:solidFill>
-                  <a:srgbClr val="000000"/>
-                </a:solidFill>
-                <a:latin typeface="Arial"/>
-              </a:rPr>
-              <a:t>5.  Disclose any API key, pretrained model or extra data used. A model trained from scratch earns more marks.</a:t>
-            </a:r>
-          </a:p>
-          <a:p>
-            <a:pPr>
-              <a:spcAft>
-                <a:spcPts val="800"/>
-              </a:spcAft>
-            </a:pPr>
-            <a:r>
-              <a:rPr b="1" sz="1800">
-                <a:solidFill>
-                  <a:srgbClr val="000000"/>
-                </a:solidFill>
-                <a:latin typeface="Arial"/>
-              </a:rPr>
-              <a:t>6.  Submit before 12:00 PM, in the way announced by the organisers.</a:t>
-            </a:r>
-          </a:p>
-        </p:txBody>
-      </p:sp>
-      <p:sp>
-        <p:nvSpPr>
-          <p:cNvPr id="13" name="TextBox 12"/>
-          <p:cNvSpPr txBox="1"/>
-          <p:nvPr/>
-        </p:nvSpPr>
-        <p:spPr>
-          <a:xfrm>
-            <a:off x="731520" y="5349240"/>
-            <a:ext cx="10789920" cy="457200"/>
-          </a:xfrm>
-          <a:prstGeom prst="rect">
-            <a:avLst/>
-          </a:prstGeom>
-          <a:noFill/>
-        </p:spPr>
-        <p:txBody>
-          <a:bodyPr wrap="square" anchor="t">
-            <a:spAutoFit/>
-          </a:bodyPr>
-          <a:lstStyle/>
-          <a:p>
-            <a:pPr algn="l"/>
-            <a:r>
-              <a:rPr sz="1600" b="1">
-                <a:solidFill>
-                  <a:srgbClr val="C00000"/>
-                </a:solidFill>
-                <a:latin typeface="Arial"/>
-              </a:rPr>
-              <a:t>Note – Delete this slide before you submit.</a:t>
             </a:r>
           </a:p>
         </p:txBody>

</xml_diff>

<commit_message>
PPT: DSC logo top-left, darker IIEC logo top-right, remove team-name oval
Co-Authored-By: Claude Sonnet 5.5 <noreply@anthropic.com>
</commit_message>
<xml_diff>
--- a/site/downloads/DATATHON-Round1-Idea-PPT-Template.pptx
+++ b/site/downloads/DATATHON-Round1-Idea-PPT-Template.pptx
@@ -3119,7 +3119,7 @@
         </p:blipFill>
         <p:spPr>
           <a:xfrm>
-            <a:off x="640080" y="228600"/>
+            <a:off x="502920" y="228600"/>
             <a:ext cx="1316397" cy="1051560"/>
           </a:xfrm>
           <a:prstGeom prst="rect">
@@ -3167,8 +3167,8 @@
         </p:blipFill>
         <p:spPr>
           <a:xfrm>
-            <a:off x="9418320" y="365760"/>
-            <a:ext cx="2053503" cy="777240"/>
+            <a:off x="9829800" y="457200"/>
+            <a:ext cx="1811915" cy="685800"/>
           </a:xfrm>
           <a:prstGeom prst="rect">
             <a:avLst/>
@@ -3448,23 +3448,106 @@
       <p:grpSpPr/>
       <p:sp>
         <p:nvSpPr>
-          <p:cNvPr id="2" name="Oval 1"/>
+          <p:cNvPr id="2" name="TextBox 1"/>
+          <p:cNvSpPr txBox="1"/>
+          <p:nvPr/>
+        </p:nvSpPr>
+        <p:spPr>
+          <a:xfrm>
+            <a:off x="1783080" y="228600"/>
+            <a:ext cx="8595360" cy="868680"/>
+          </a:xfrm>
+          <a:prstGeom prst="rect">
+            <a:avLst/>
+          </a:prstGeom>
+          <a:noFill/>
+        </p:spPr>
+        <p:txBody>
+          <a:bodyPr wrap="square" anchor="ctr">
+            <a:spAutoFit/>
+          </a:bodyPr>
+          <a:lstStyle/>
+          <a:p>
+            <a:pPr algn="ctr"/>
+            <a:r>
+              <a:rPr sz="3000" b="0">
+                <a:solidFill>
+                  <a:srgbClr val="000000"/>
+                </a:solidFill>
+                <a:latin typeface="Arial Black"/>
+              </a:rPr>
+              <a:t>PROBLEM &amp; TARGET USER</a:t>
+            </a:r>
+          </a:p>
+        </p:txBody>
+      </p:sp>
+      <p:pic>
+        <p:nvPicPr>
+          <p:cNvPr id="3" name="Picture 2" descr="logo-dsc-light.png"/>
+          <p:cNvPicPr>
+            <a:picLocks noChangeAspect="1"/>
+          </p:cNvPicPr>
+          <p:nvPr/>
+        </p:nvPicPr>
+        <p:blipFill>
+          <a:blip r:embed="rId2"/>
+          <a:stretch>
+            <a:fillRect/>
+          </a:stretch>
+        </p:blipFill>
+        <p:spPr>
+          <a:xfrm>
+            <a:off x="411480" y="137160"/>
+            <a:ext cx="1144693" cy="914400"/>
+          </a:xfrm>
+          <a:prstGeom prst="rect">
+            <a:avLst/>
+          </a:prstGeom>
+        </p:spPr>
+      </p:pic>
+      <p:pic>
+        <p:nvPicPr>
+          <p:cNvPr id="4" name="Picture 3" descr="logo-iiec-light.png"/>
+          <p:cNvPicPr>
+            <a:picLocks noChangeAspect="1"/>
+          </p:cNvPicPr>
+          <p:nvPr/>
+        </p:nvPicPr>
+        <p:blipFill>
+          <a:blip r:embed="rId3"/>
+          <a:stretch>
+            <a:fillRect/>
+          </a:stretch>
+        </p:blipFill>
+        <p:spPr>
+          <a:xfrm>
+            <a:off x="10241280" y="320040"/>
+            <a:ext cx="1497850" cy="566928"/>
+          </a:xfrm>
+          <a:prstGeom prst="rect">
+            <a:avLst/>
+          </a:prstGeom>
+        </p:spPr>
+      </p:pic>
+      <p:sp>
+        <p:nvSpPr>
+          <p:cNvPr id="5" name="Rectangle 4"/>
           <p:cNvSpPr/>
           <p:nvPr/>
         </p:nvSpPr>
         <p:spPr>
           <a:xfrm>
-            <a:off x="365760" y="274320"/>
-            <a:ext cx="1463040" cy="777240"/>
-          </a:xfrm>
-          <a:prstGeom prst="ellipse">
-            <a:avLst/>
-          </a:prstGeom>
-          <a:noFill/>
-          <a:ln w="31750">
-            <a:solidFill>
-              <a:srgbClr val="19E3F5"/>
-            </a:solidFill>
+            <a:off x="0" y="6355080"/>
+            <a:ext cx="12191695" cy="502920"/>
+          </a:xfrm>
+          <a:prstGeom prst="rect">
+            <a:avLst/>
+          </a:prstGeom>
+          <a:solidFill>
+            <a:srgbClr val="19E3F5"/>
+          </a:solidFill>
+          <a:ln>
+            <a:noFill/>
           </a:ln>
           <a:effectLst/>
         </p:spPr>
@@ -3483,32 +3566,23 @@
           </a:fontRef>
         </p:style>
         <p:txBody>
-          <a:bodyPr rtlCol="0" anchor="ctr" wrap="square"/>
+          <a:bodyPr rtlCol="0" anchor="ctr"/>
           <a:lstStyle/>
           <a:p>
             <a:pPr algn="ctr"/>
-            <a:r>
-              <a:rPr sz="1200" b="0">
-                <a:solidFill>
-                  <a:srgbClr val="000000"/>
-                </a:solidFill>
-                <a:latin typeface="Arial"/>
-              </a:rPr>
-              <a:t>Your Team Name</a:t>
-            </a:r>
-          </a:p>
-        </p:txBody>
-      </p:sp>
-      <p:sp>
-        <p:nvSpPr>
-          <p:cNvPr id="3" name="TextBox 2"/>
+          </a:p>
+        </p:txBody>
+      </p:sp>
+      <p:sp>
+        <p:nvSpPr>
+          <p:cNvPr id="6" name="TextBox 5"/>
           <p:cNvSpPr txBox="1"/>
           <p:nvPr/>
         </p:nvSpPr>
         <p:spPr>
           <a:xfrm>
-            <a:off x="1920240" y="228600"/>
-            <a:ext cx="7406640" cy="868680"/>
+            <a:off x="0" y="6355080"/>
+            <a:ext cx="12191695" cy="502920"/>
           </a:xfrm>
           <a:prstGeom prst="rect">
             <a:avLst/>
@@ -3523,106 +3597,14 @@
           <a:p>
             <a:pPr algn="ctr"/>
             <a:r>
-              <a:rPr sz="3000" b="0">
-                <a:solidFill>
-                  <a:srgbClr val="000000"/>
-                </a:solidFill>
-                <a:latin typeface="Arial Black"/>
-              </a:rPr>
-              <a:t>PROBLEM &amp; TARGET USER</a:t>
-            </a:r>
-          </a:p>
-        </p:txBody>
-      </p:sp>
-      <p:pic>
-        <p:nvPicPr>
-          <p:cNvPr id="4" name="Picture 3" descr="logo-dsc-light.png"/>
-          <p:cNvPicPr>
-            <a:picLocks noChangeAspect="1"/>
-          </p:cNvPicPr>
-          <p:nvPr/>
-        </p:nvPicPr>
-        <p:blipFill>
-          <a:blip r:embed="rId2"/>
-          <a:stretch>
-            <a:fillRect/>
-          </a:stretch>
-        </p:blipFill>
-        <p:spPr>
-          <a:xfrm>
-            <a:off x="9326880" y="182880"/>
-            <a:ext cx="1087459" cy="868680"/>
-          </a:xfrm>
-          <a:prstGeom prst="rect">
-            <a:avLst/>
-          </a:prstGeom>
-        </p:spPr>
-      </p:pic>
-      <p:pic>
-        <p:nvPicPr>
-          <p:cNvPr id="5" name="Picture 4" descr="logo-iiec-light.png"/>
-          <p:cNvPicPr>
-            <a:picLocks noChangeAspect="1"/>
-          </p:cNvPicPr>
-          <p:nvPr/>
-        </p:nvPicPr>
-        <p:blipFill>
-          <a:blip r:embed="rId3"/>
-          <a:stretch>
-            <a:fillRect/>
-          </a:stretch>
-        </p:blipFill>
-        <p:spPr>
-          <a:xfrm>
-            <a:off x="10698480" y="384048"/>
-            <a:ext cx="1328738" cy="502920"/>
-          </a:xfrm>
-          <a:prstGeom prst="rect">
-            <a:avLst/>
-          </a:prstGeom>
-        </p:spPr>
-      </p:pic>
-      <p:sp>
-        <p:nvSpPr>
-          <p:cNvPr id="6" name="Rectangle 5"/>
-          <p:cNvSpPr/>
-          <p:nvPr/>
-        </p:nvSpPr>
-        <p:spPr>
-          <a:xfrm>
-            <a:off x="0" y="6355080"/>
-            <a:ext cx="12191695" cy="502920"/>
-          </a:xfrm>
-          <a:prstGeom prst="rect">
-            <a:avLst/>
-          </a:prstGeom>
-          <a:solidFill>
-            <a:srgbClr val="19E3F5"/>
-          </a:solidFill>
-          <a:ln>
-            <a:noFill/>
-          </a:ln>
-          <a:effectLst/>
-        </p:spPr>
-        <p:style>
-          <a:lnRef idx="1">
-            <a:schemeClr val="accent1"/>
-          </a:lnRef>
-          <a:fillRef idx="3">
-            <a:schemeClr val="accent1"/>
-          </a:fillRef>
-          <a:effectRef idx="2">
-            <a:schemeClr val="accent1"/>
-          </a:effectRef>
-          <a:fontRef idx="minor">
-            <a:schemeClr val="lt1"/>
-          </a:fontRef>
-        </p:style>
-        <p:txBody>
-          <a:bodyPr rtlCol="0" anchor="ctr"/>
-          <a:lstStyle/>
-          <a:p>
-            <a:pPr algn="ctr"/>
+              <a:rPr sz="1200" b="1">
+                <a:solidFill>
+                  <a:srgbClr val="000000"/>
+                </a:solidFill>
+                <a:latin typeface="Arial"/>
+              </a:rPr>
+              <a:t>DATATHON 2026  ·  Round 1 Idea Submission – Template</a:t>
+            </a:r>
           </a:p>
         </p:txBody>
       </p:sp>
@@ -3634,8 +3616,8 @@
         </p:nvSpPr>
         <p:spPr>
           <a:xfrm>
-            <a:off x="0" y="6355080"/>
-            <a:ext cx="12191695" cy="502920"/>
+            <a:off x="10881360" y="6355080"/>
+            <a:ext cx="1005840" cy="502920"/>
           </a:xfrm>
           <a:prstGeom prst="rect">
             <a:avLst/>
@@ -3648,15 +3630,15 @@
           </a:bodyPr>
           <a:lstStyle/>
           <a:p>
-            <a:pPr algn="ctr"/>
-            <a:r>
-              <a:rPr sz="1200" b="1">
+            <a:pPr algn="r"/>
+            <a:r>
+              <a:rPr sz="1300" b="1">
                 <a:solidFill>
                   <a:srgbClr val="000000"/>
                 </a:solidFill>
                 <a:latin typeface="Arial"/>
               </a:rPr>
-              <a:t>DATATHON 2026  ·  Round 1 Idea Submission – Template</a:t>
+              <a:t>2</a:t>
             </a:r>
           </a:p>
         </p:txBody>
@@ -3664,41 +3646,6 @@
       <p:sp>
         <p:nvSpPr>
           <p:cNvPr id="8" name="TextBox 7"/>
-          <p:cNvSpPr txBox="1"/>
-          <p:nvPr/>
-        </p:nvSpPr>
-        <p:spPr>
-          <a:xfrm>
-            <a:off x="10881360" y="6355080"/>
-            <a:ext cx="1005840" cy="502920"/>
-          </a:xfrm>
-          <a:prstGeom prst="rect">
-            <a:avLst/>
-          </a:prstGeom>
-          <a:noFill/>
-        </p:spPr>
-        <p:txBody>
-          <a:bodyPr wrap="square" anchor="ctr">
-            <a:spAutoFit/>
-          </a:bodyPr>
-          <a:lstStyle/>
-          <a:p>
-            <a:pPr algn="r"/>
-            <a:r>
-              <a:rPr sz="1300" b="1">
-                <a:solidFill>
-                  <a:srgbClr val="000000"/>
-                </a:solidFill>
-                <a:latin typeface="Arial"/>
-              </a:rPr>
-              <a:t>2</a:t>
-            </a:r>
-          </a:p>
-        </p:txBody>
-      </p:sp>
-      <p:sp>
-        <p:nvSpPr>
-          <p:cNvPr id="9" name="TextBox 8"/>
           <p:cNvSpPr txBox="1"/>
           <p:nvPr/>
         </p:nvSpPr>
@@ -3742,7 +3689,7 @@
       </p:sp>
       <p:sp>
         <p:nvSpPr>
-          <p:cNvPr id="10" name="TextBox 9"/>
+          <p:cNvPr id="9" name="TextBox 8"/>
           <p:cNvSpPr txBox="1"/>
           <p:nvPr/>
         </p:nvSpPr>
@@ -3845,23 +3792,106 @@
       <p:grpSpPr/>
       <p:sp>
         <p:nvSpPr>
-          <p:cNvPr id="2" name="Oval 1"/>
+          <p:cNvPr id="2" name="TextBox 1"/>
+          <p:cNvSpPr txBox="1"/>
+          <p:nvPr/>
+        </p:nvSpPr>
+        <p:spPr>
+          <a:xfrm>
+            <a:off x="1783080" y="228600"/>
+            <a:ext cx="8595360" cy="868680"/>
+          </a:xfrm>
+          <a:prstGeom prst="rect">
+            <a:avLst/>
+          </a:prstGeom>
+          <a:noFill/>
+        </p:spPr>
+        <p:txBody>
+          <a:bodyPr wrap="square" anchor="ctr">
+            <a:spAutoFit/>
+          </a:bodyPr>
+          <a:lstStyle/>
+          <a:p>
+            <a:pPr algn="ctr"/>
+            <a:r>
+              <a:rPr sz="3000" b="0">
+                <a:solidFill>
+                  <a:srgbClr val="000000"/>
+                </a:solidFill>
+                <a:latin typeface="Arial Black"/>
+              </a:rPr>
+              <a:t>SOLUTION &amp; USP</a:t>
+            </a:r>
+          </a:p>
+        </p:txBody>
+      </p:sp>
+      <p:pic>
+        <p:nvPicPr>
+          <p:cNvPr id="3" name="Picture 2" descr="logo-dsc-light.png"/>
+          <p:cNvPicPr>
+            <a:picLocks noChangeAspect="1"/>
+          </p:cNvPicPr>
+          <p:nvPr/>
+        </p:nvPicPr>
+        <p:blipFill>
+          <a:blip r:embed="rId2"/>
+          <a:stretch>
+            <a:fillRect/>
+          </a:stretch>
+        </p:blipFill>
+        <p:spPr>
+          <a:xfrm>
+            <a:off x="411480" y="137160"/>
+            <a:ext cx="1144693" cy="914400"/>
+          </a:xfrm>
+          <a:prstGeom prst="rect">
+            <a:avLst/>
+          </a:prstGeom>
+        </p:spPr>
+      </p:pic>
+      <p:pic>
+        <p:nvPicPr>
+          <p:cNvPr id="4" name="Picture 3" descr="logo-iiec-light.png"/>
+          <p:cNvPicPr>
+            <a:picLocks noChangeAspect="1"/>
+          </p:cNvPicPr>
+          <p:nvPr/>
+        </p:nvPicPr>
+        <p:blipFill>
+          <a:blip r:embed="rId3"/>
+          <a:stretch>
+            <a:fillRect/>
+          </a:stretch>
+        </p:blipFill>
+        <p:spPr>
+          <a:xfrm>
+            <a:off x="10241280" y="320040"/>
+            <a:ext cx="1497850" cy="566928"/>
+          </a:xfrm>
+          <a:prstGeom prst="rect">
+            <a:avLst/>
+          </a:prstGeom>
+        </p:spPr>
+      </p:pic>
+      <p:sp>
+        <p:nvSpPr>
+          <p:cNvPr id="5" name="Rectangle 4"/>
           <p:cNvSpPr/>
           <p:nvPr/>
         </p:nvSpPr>
         <p:spPr>
           <a:xfrm>
-            <a:off x="365760" y="274320"/>
-            <a:ext cx="1463040" cy="777240"/>
-          </a:xfrm>
-          <a:prstGeom prst="ellipse">
-            <a:avLst/>
-          </a:prstGeom>
-          <a:noFill/>
-          <a:ln w="31750">
-            <a:solidFill>
-              <a:srgbClr val="19E3F5"/>
-            </a:solidFill>
+            <a:off x="0" y="6355080"/>
+            <a:ext cx="12191695" cy="502920"/>
+          </a:xfrm>
+          <a:prstGeom prst="rect">
+            <a:avLst/>
+          </a:prstGeom>
+          <a:solidFill>
+            <a:srgbClr val="19E3F5"/>
+          </a:solidFill>
+          <a:ln>
+            <a:noFill/>
           </a:ln>
           <a:effectLst/>
         </p:spPr>
@@ -3880,32 +3910,23 @@
           </a:fontRef>
         </p:style>
         <p:txBody>
-          <a:bodyPr rtlCol="0" anchor="ctr" wrap="square"/>
+          <a:bodyPr rtlCol="0" anchor="ctr"/>
           <a:lstStyle/>
           <a:p>
             <a:pPr algn="ctr"/>
-            <a:r>
-              <a:rPr sz="1200" b="0">
-                <a:solidFill>
-                  <a:srgbClr val="000000"/>
-                </a:solidFill>
-                <a:latin typeface="Arial"/>
-              </a:rPr>
-              <a:t>Your Team Name</a:t>
-            </a:r>
-          </a:p>
-        </p:txBody>
-      </p:sp>
-      <p:sp>
-        <p:nvSpPr>
-          <p:cNvPr id="3" name="TextBox 2"/>
+          </a:p>
+        </p:txBody>
+      </p:sp>
+      <p:sp>
+        <p:nvSpPr>
+          <p:cNvPr id="6" name="TextBox 5"/>
           <p:cNvSpPr txBox="1"/>
           <p:nvPr/>
         </p:nvSpPr>
         <p:spPr>
           <a:xfrm>
-            <a:off x="1920240" y="228600"/>
-            <a:ext cx="7406640" cy="868680"/>
+            <a:off x="0" y="6355080"/>
+            <a:ext cx="12191695" cy="502920"/>
           </a:xfrm>
           <a:prstGeom prst="rect">
             <a:avLst/>
@@ -3920,106 +3941,14 @@
           <a:p>
             <a:pPr algn="ctr"/>
             <a:r>
-              <a:rPr sz="3000" b="0">
-                <a:solidFill>
-                  <a:srgbClr val="000000"/>
-                </a:solidFill>
-                <a:latin typeface="Arial Black"/>
-              </a:rPr>
-              <a:t>SOLUTION &amp; USP</a:t>
-            </a:r>
-          </a:p>
-        </p:txBody>
-      </p:sp>
-      <p:pic>
-        <p:nvPicPr>
-          <p:cNvPr id="4" name="Picture 3" descr="logo-dsc-light.png"/>
-          <p:cNvPicPr>
-            <a:picLocks noChangeAspect="1"/>
-          </p:cNvPicPr>
-          <p:nvPr/>
-        </p:nvPicPr>
-        <p:blipFill>
-          <a:blip r:embed="rId2"/>
-          <a:stretch>
-            <a:fillRect/>
-          </a:stretch>
-        </p:blipFill>
-        <p:spPr>
-          <a:xfrm>
-            <a:off x="9326880" y="182880"/>
-            <a:ext cx="1087459" cy="868680"/>
-          </a:xfrm>
-          <a:prstGeom prst="rect">
-            <a:avLst/>
-          </a:prstGeom>
-        </p:spPr>
-      </p:pic>
-      <p:pic>
-        <p:nvPicPr>
-          <p:cNvPr id="5" name="Picture 4" descr="logo-iiec-light.png"/>
-          <p:cNvPicPr>
-            <a:picLocks noChangeAspect="1"/>
-          </p:cNvPicPr>
-          <p:nvPr/>
-        </p:nvPicPr>
-        <p:blipFill>
-          <a:blip r:embed="rId3"/>
-          <a:stretch>
-            <a:fillRect/>
-          </a:stretch>
-        </p:blipFill>
-        <p:spPr>
-          <a:xfrm>
-            <a:off x="10698480" y="384048"/>
-            <a:ext cx="1328738" cy="502920"/>
-          </a:xfrm>
-          <a:prstGeom prst="rect">
-            <a:avLst/>
-          </a:prstGeom>
-        </p:spPr>
-      </p:pic>
-      <p:sp>
-        <p:nvSpPr>
-          <p:cNvPr id="6" name="Rectangle 5"/>
-          <p:cNvSpPr/>
-          <p:nvPr/>
-        </p:nvSpPr>
-        <p:spPr>
-          <a:xfrm>
-            <a:off x="0" y="6355080"/>
-            <a:ext cx="12191695" cy="502920"/>
-          </a:xfrm>
-          <a:prstGeom prst="rect">
-            <a:avLst/>
-          </a:prstGeom>
-          <a:solidFill>
-            <a:srgbClr val="19E3F5"/>
-          </a:solidFill>
-          <a:ln>
-            <a:noFill/>
-          </a:ln>
-          <a:effectLst/>
-        </p:spPr>
-        <p:style>
-          <a:lnRef idx="1">
-            <a:schemeClr val="accent1"/>
-          </a:lnRef>
-          <a:fillRef idx="3">
-            <a:schemeClr val="accent1"/>
-          </a:fillRef>
-          <a:effectRef idx="2">
-            <a:schemeClr val="accent1"/>
-          </a:effectRef>
-          <a:fontRef idx="minor">
-            <a:schemeClr val="lt1"/>
-          </a:fontRef>
-        </p:style>
-        <p:txBody>
-          <a:bodyPr rtlCol="0" anchor="ctr"/>
-          <a:lstStyle/>
-          <a:p>
-            <a:pPr algn="ctr"/>
+              <a:rPr sz="1200" b="1">
+                <a:solidFill>
+                  <a:srgbClr val="000000"/>
+                </a:solidFill>
+                <a:latin typeface="Arial"/>
+              </a:rPr>
+              <a:t>DATATHON 2026  ·  Round 1 Idea Submission – Template</a:t>
+            </a:r>
           </a:p>
         </p:txBody>
       </p:sp>
@@ -4031,8 +3960,8 @@
         </p:nvSpPr>
         <p:spPr>
           <a:xfrm>
-            <a:off x="0" y="6355080"/>
-            <a:ext cx="12191695" cy="502920"/>
+            <a:off x="10881360" y="6355080"/>
+            <a:ext cx="1005840" cy="502920"/>
           </a:xfrm>
           <a:prstGeom prst="rect">
             <a:avLst/>
@@ -4045,15 +3974,15 @@
           </a:bodyPr>
           <a:lstStyle/>
           <a:p>
-            <a:pPr algn="ctr"/>
-            <a:r>
-              <a:rPr sz="1200" b="1">
+            <a:pPr algn="r"/>
+            <a:r>
+              <a:rPr sz="1300" b="1">
                 <a:solidFill>
                   <a:srgbClr val="000000"/>
                 </a:solidFill>
                 <a:latin typeface="Arial"/>
               </a:rPr>
-              <a:t>DATATHON 2026  ·  Round 1 Idea Submission – Template</a:t>
+              <a:t>3</a:t>
             </a:r>
           </a:p>
         </p:txBody>
@@ -4061,41 +3990,6 @@
       <p:sp>
         <p:nvSpPr>
           <p:cNvPr id="8" name="TextBox 7"/>
-          <p:cNvSpPr txBox="1"/>
-          <p:nvPr/>
-        </p:nvSpPr>
-        <p:spPr>
-          <a:xfrm>
-            <a:off x="10881360" y="6355080"/>
-            <a:ext cx="1005840" cy="502920"/>
-          </a:xfrm>
-          <a:prstGeom prst="rect">
-            <a:avLst/>
-          </a:prstGeom>
-          <a:noFill/>
-        </p:spPr>
-        <p:txBody>
-          <a:bodyPr wrap="square" anchor="ctr">
-            <a:spAutoFit/>
-          </a:bodyPr>
-          <a:lstStyle/>
-          <a:p>
-            <a:pPr algn="r"/>
-            <a:r>
-              <a:rPr sz="1300" b="1">
-                <a:solidFill>
-                  <a:srgbClr val="000000"/>
-                </a:solidFill>
-                <a:latin typeface="Arial"/>
-              </a:rPr>
-              <a:t>3</a:t>
-            </a:r>
-          </a:p>
-        </p:txBody>
-      </p:sp>
-      <p:sp>
-        <p:nvSpPr>
-          <p:cNvPr id="9" name="TextBox 8"/>
           <p:cNvSpPr txBox="1"/>
           <p:nvPr/>
         </p:nvSpPr>
@@ -4139,7 +4033,7 @@
       </p:sp>
       <p:sp>
         <p:nvSpPr>
-          <p:cNvPr id="10" name="TextBox 9"/>
+          <p:cNvPr id="9" name="TextBox 8"/>
           <p:cNvSpPr txBox="1"/>
           <p:nvPr/>
         </p:nvSpPr>
@@ -4198,7 +4092,7 @@
       </p:sp>
       <p:sp>
         <p:nvSpPr>
-          <p:cNvPr id="11" name="TextBox 10"/>
+          <p:cNvPr id="10" name="TextBox 9"/>
           <p:cNvSpPr txBox="1"/>
           <p:nvPr/>
         </p:nvSpPr>
@@ -4251,7 +4145,7 @@
       </p:sp>
       <p:sp>
         <p:nvSpPr>
-          <p:cNvPr id="12" name="TextBox 11"/>
+          <p:cNvPr id="11" name="TextBox 10"/>
           <p:cNvSpPr txBox="1"/>
           <p:nvPr/>
         </p:nvSpPr>
@@ -4336,23 +4230,106 @@
       <p:grpSpPr/>
       <p:sp>
         <p:nvSpPr>
-          <p:cNvPr id="2" name="Oval 1"/>
+          <p:cNvPr id="2" name="TextBox 1"/>
+          <p:cNvSpPr txBox="1"/>
+          <p:nvPr/>
+        </p:nvSpPr>
+        <p:spPr>
+          <a:xfrm>
+            <a:off x="1783080" y="228600"/>
+            <a:ext cx="8595360" cy="868680"/>
+          </a:xfrm>
+          <a:prstGeom prst="rect">
+            <a:avLst/>
+          </a:prstGeom>
+          <a:noFill/>
+        </p:spPr>
+        <p:txBody>
+          <a:bodyPr wrap="square" anchor="ctr">
+            <a:spAutoFit/>
+          </a:bodyPr>
+          <a:lstStyle/>
+          <a:p>
+            <a:pPr algn="ctr"/>
+            <a:r>
+              <a:rPr sz="3000" b="0">
+                <a:solidFill>
+                  <a:srgbClr val="000000"/>
+                </a:solidFill>
+                <a:latin typeface="Arial Black"/>
+              </a:rPr>
+              <a:t>DATASET &amp; INSIGHTS</a:t>
+            </a:r>
+          </a:p>
+        </p:txBody>
+      </p:sp>
+      <p:pic>
+        <p:nvPicPr>
+          <p:cNvPr id="3" name="Picture 2" descr="logo-dsc-light.png"/>
+          <p:cNvPicPr>
+            <a:picLocks noChangeAspect="1"/>
+          </p:cNvPicPr>
+          <p:nvPr/>
+        </p:nvPicPr>
+        <p:blipFill>
+          <a:blip r:embed="rId2"/>
+          <a:stretch>
+            <a:fillRect/>
+          </a:stretch>
+        </p:blipFill>
+        <p:spPr>
+          <a:xfrm>
+            <a:off x="411480" y="137160"/>
+            <a:ext cx="1144693" cy="914400"/>
+          </a:xfrm>
+          <a:prstGeom prst="rect">
+            <a:avLst/>
+          </a:prstGeom>
+        </p:spPr>
+      </p:pic>
+      <p:pic>
+        <p:nvPicPr>
+          <p:cNvPr id="4" name="Picture 3" descr="logo-iiec-light.png"/>
+          <p:cNvPicPr>
+            <a:picLocks noChangeAspect="1"/>
+          </p:cNvPicPr>
+          <p:nvPr/>
+        </p:nvPicPr>
+        <p:blipFill>
+          <a:blip r:embed="rId3"/>
+          <a:stretch>
+            <a:fillRect/>
+          </a:stretch>
+        </p:blipFill>
+        <p:spPr>
+          <a:xfrm>
+            <a:off x="10241280" y="320040"/>
+            <a:ext cx="1497850" cy="566928"/>
+          </a:xfrm>
+          <a:prstGeom prst="rect">
+            <a:avLst/>
+          </a:prstGeom>
+        </p:spPr>
+      </p:pic>
+      <p:sp>
+        <p:nvSpPr>
+          <p:cNvPr id="5" name="Rectangle 4"/>
           <p:cNvSpPr/>
           <p:nvPr/>
         </p:nvSpPr>
         <p:spPr>
           <a:xfrm>
-            <a:off x="365760" y="274320"/>
-            <a:ext cx="1463040" cy="777240"/>
-          </a:xfrm>
-          <a:prstGeom prst="ellipse">
-            <a:avLst/>
-          </a:prstGeom>
-          <a:noFill/>
-          <a:ln w="31750">
-            <a:solidFill>
-              <a:srgbClr val="19E3F5"/>
-            </a:solidFill>
+            <a:off x="0" y="6355080"/>
+            <a:ext cx="12191695" cy="502920"/>
+          </a:xfrm>
+          <a:prstGeom prst="rect">
+            <a:avLst/>
+          </a:prstGeom>
+          <a:solidFill>
+            <a:srgbClr val="19E3F5"/>
+          </a:solidFill>
+          <a:ln>
+            <a:noFill/>
           </a:ln>
           <a:effectLst/>
         </p:spPr>
@@ -4371,32 +4348,23 @@
           </a:fontRef>
         </p:style>
         <p:txBody>
-          <a:bodyPr rtlCol="0" anchor="ctr" wrap="square"/>
+          <a:bodyPr rtlCol="0" anchor="ctr"/>
           <a:lstStyle/>
           <a:p>
             <a:pPr algn="ctr"/>
-            <a:r>
-              <a:rPr sz="1200" b="0">
-                <a:solidFill>
-                  <a:srgbClr val="000000"/>
-                </a:solidFill>
-                <a:latin typeface="Arial"/>
-              </a:rPr>
-              <a:t>Your Team Name</a:t>
-            </a:r>
-          </a:p>
-        </p:txBody>
-      </p:sp>
-      <p:sp>
-        <p:nvSpPr>
-          <p:cNvPr id="3" name="TextBox 2"/>
+          </a:p>
+        </p:txBody>
+      </p:sp>
+      <p:sp>
+        <p:nvSpPr>
+          <p:cNvPr id="6" name="TextBox 5"/>
           <p:cNvSpPr txBox="1"/>
           <p:nvPr/>
         </p:nvSpPr>
         <p:spPr>
           <a:xfrm>
-            <a:off x="1920240" y="228600"/>
-            <a:ext cx="7406640" cy="868680"/>
+            <a:off x="0" y="6355080"/>
+            <a:ext cx="12191695" cy="502920"/>
           </a:xfrm>
           <a:prstGeom prst="rect">
             <a:avLst/>
@@ -4411,106 +4379,14 @@
           <a:p>
             <a:pPr algn="ctr"/>
             <a:r>
-              <a:rPr sz="3000" b="0">
-                <a:solidFill>
-                  <a:srgbClr val="000000"/>
-                </a:solidFill>
-                <a:latin typeface="Arial Black"/>
-              </a:rPr>
-              <a:t>DATASET &amp; INSIGHTS</a:t>
-            </a:r>
-          </a:p>
-        </p:txBody>
-      </p:sp>
-      <p:pic>
-        <p:nvPicPr>
-          <p:cNvPr id="4" name="Picture 3" descr="logo-dsc-light.png"/>
-          <p:cNvPicPr>
-            <a:picLocks noChangeAspect="1"/>
-          </p:cNvPicPr>
-          <p:nvPr/>
-        </p:nvPicPr>
-        <p:blipFill>
-          <a:blip r:embed="rId2"/>
-          <a:stretch>
-            <a:fillRect/>
-          </a:stretch>
-        </p:blipFill>
-        <p:spPr>
-          <a:xfrm>
-            <a:off x="9326880" y="182880"/>
-            <a:ext cx="1087459" cy="868680"/>
-          </a:xfrm>
-          <a:prstGeom prst="rect">
-            <a:avLst/>
-          </a:prstGeom>
-        </p:spPr>
-      </p:pic>
-      <p:pic>
-        <p:nvPicPr>
-          <p:cNvPr id="5" name="Picture 4" descr="logo-iiec-light.png"/>
-          <p:cNvPicPr>
-            <a:picLocks noChangeAspect="1"/>
-          </p:cNvPicPr>
-          <p:nvPr/>
-        </p:nvPicPr>
-        <p:blipFill>
-          <a:blip r:embed="rId3"/>
-          <a:stretch>
-            <a:fillRect/>
-          </a:stretch>
-        </p:blipFill>
-        <p:spPr>
-          <a:xfrm>
-            <a:off x="10698480" y="384048"/>
-            <a:ext cx="1328738" cy="502920"/>
-          </a:xfrm>
-          <a:prstGeom prst="rect">
-            <a:avLst/>
-          </a:prstGeom>
-        </p:spPr>
-      </p:pic>
-      <p:sp>
-        <p:nvSpPr>
-          <p:cNvPr id="6" name="Rectangle 5"/>
-          <p:cNvSpPr/>
-          <p:nvPr/>
-        </p:nvSpPr>
-        <p:spPr>
-          <a:xfrm>
-            <a:off x="0" y="6355080"/>
-            <a:ext cx="12191695" cy="502920"/>
-          </a:xfrm>
-          <a:prstGeom prst="rect">
-            <a:avLst/>
-          </a:prstGeom>
-          <a:solidFill>
-            <a:srgbClr val="19E3F5"/>
-          </a:solidFill>
-          <a:ln>
-            <a:noFill/>
-          </a:ln>
-          <a:effectLst/>
-        </p:spPr>
-        <p:style>
-          <a:lnRef idx="1">
-            <a:schemeClr val="accent1"/>
-          </a:lnRef>
-          <a:fillRef idx="3">
-            <a:schemeClr val="accent1"/>
-          </a:fillRef>
-          <a:effectRef idx="2">
-            <a:schemeClr val="accent1"/>
-          </a:effectRef>
-          <a:fontRef idx="minor">
-            <a:schemeClr val="lt1"/>
-          </a:fontRef>
-        </p:style>
-        <p:txBody>
-          <a:bodyPr rtlCol="0" anchor="ctr"/>
-          <a:lstStyle/>
-          <a:p>
-            <a:pPr algn="ctr"/>
+              <a:rPr sz="1200" b="1">
+                <a:solidFill>
+                  <a:srgbClr val="000000"/>
+                </a:solidFill>
+                <a:latin typeface="Arial"/>
+              </a:rPr>
+              <a:t>DATATHON 2026  ·  Round 1 Idea Submission – Template</a:t>
+            </a:r>
           </a:p>
         </p:txBody>
       </p:sp>
@@ -4522,8 +4398,8 @@
         </p:nvSpPr>
         <p:spPr>
           <a:xfrm>
-            <a:off x="0" y="6355080"/>
-            <a:ext cx="12191695" cy="502920"/>
+            <a:off x="10881360" y="6355080"/>
+            <a:ext cx="1005840" cy="502920"/>
           </a:xfrm>
           <a:prstGeom prst="rect">
             <a:avLst/>
@@ -4536,15 +4412,15 @@
           </a:bodyPr>
           <a:lstStyle/>
           <a:p>
-            <a:pPr algn="ctr"/>
-            <a:r>
-              <a:rPr sz="1200" b="1">
+            <a:pPr algn="r"/>
+            <a:r>
+              <a:rPr sz="1300" b="1">
                 <a:solidFill>
                   <a:srgbClr val="000000"/>
                 </a:solidFill>
                 <a:latin typeface="Arial"/>
               </a:rPr>
-              <a:t>DATATHON 2026  ·  Round 1 Idea Submission – Template</a:t>
+              <a:t>4</a:t>
             </a:r>
           </a:p>
         </p:txBody>
@@ -4552,41 +4428,6 @@
       <p:sp>
         <p:nvSpPr>
           <p:cNvPr id="8" name="TextBox 7"/>
-          <p:cNvSpPr txBox="1"/>
-          <p:nvPr/>
-        </p:nvSpPr>
-        <p:spPr>
-          <a:xfrm>
-            <a:off x="10881360" y="6355080"/>
-            <a:ext cx="1005840" cy="502920"/>
-          </a:xfrm>
-          <a:prstGeom prst="rect">
-            <a:avLst/>
-          </a:prstGeom>
-          <a:noFill/>
-        </p:spPr>
-        <p:txBody>
-          <a:bodyPr wrap="square" anchor="ctr">
-            <a:spAutoFit/>
-          </a:bodyPr>
-          <a:lstStyle/>
-          <a:p>
-            <a:pPr algn="r"/>
-            <a:r>
-              <a:rPr sz="1300" b="1">
-                <a:solidFill>
-                  <a:srgbClr val="000000"/>
-                </a:solidFill>
-                <a:latin typeface="Arial"/>
-              </a:rPr>
-              <a:t>4</a:t>
-            </a:r>
-          </a:p>
-        </p:txBody>
-      </p:sp>
-      <p:sp>
-        <p:nvSpPr>
-          <p:cNvPr id="9" name="TextBox 8"/>
           <p:cNvSpPr txBox="1"/>
           <p:nvPr/>
         </p:nvSpPr>
@@ -4630,7 +4471,7 @@
       </p:sp>
       <p:sp>
         <p:nvSpPr>
-          <p:cNvPr id="10" name="TextBox 9"/>
+          <p:cNvPr id="9" name="TextBox 8"/>
           <p:cNvSpPr txBox="1"/>
           <p:nvPr/>
         </p:nvSpPr>
@@ -4733,23 +4574,106 @@
       <p:grpSpPr/>
       <p:sp>
         <p:nvSpPr>
-          <p:cNvPr id="2" name="Oval 1"/>
+          <p:cNvPr id="2" name="TextBox 1"/>
+          <p:cNvSpPr txBox="1"/>
+          <p:nvPr/>
+        </p:nvSpPr>
+        <p:spPr>
+          <a:xfrm>
+            <a:off x="1783080" y="228600"/>
+            <a:ext cx="8595360" cy="868680"/>
+          </a:xfrm>
+          <a:prstGeom prst="rect">
+            <a:avLst/>
+          </a:prstGeom>
+          <a:noFill/>
+        </p:spPr>
+        <p:txBody>
+          <a:bodyPr wrap="square" anchor="ctr">
+            <a:spAutoFit/>
+          </a:bodyPr>
+          <a:lstStyle/>
+          <a:p>
+            <a:pPr algn="ctr"/>
+            <a:r>
+              <a:rPr sz="3000" b="0">
+                <a:solidFill>
+                  <a:srgbClr val="000000"/>
+                </a:solidFill>
+                <a:latin typeface="Arial Black"/>
+              </a:rPr>
+              <a:t>ML MODEL</a:t>
+            </a:r>
+          </a:p>
+        </p:txBody>
+      </p:sp>
+      <p:pic>
+        <p:nvPicPr>
+          <p:cNvPr id="3" name="Picture 2" descr="logo-dsc-light.png"/>
+          <p:cNvPicPr>
+            <a:picLocks noChangeAspect="1"/>
+          </p:cNvPicPr>
+          <p:nvPr/>
+        </p:nvPicPr>
+        <p:blipFill>
+          <a:blip r:embed="rId2"/>
+          <a:stretch>
+            <a:fillRect/>
+          </a:stretch>
+        </p:blipFill>
+        <p:spPr>
+          <a:xfrm>
+            <a:off x="411480" y="137160"/>
+            <a:ext cx="1144693" cy="914400"/>
+          </a:xfrm>
+          <a:prstGeom prst="rect">
+            <a:avLst/>
+          </a:prstGeom>
+        </p:spPr>
+      </p:pic>
+      <p:pic>
+        <p:nvPicPr>
+          <p:cNvPr id="4" name="Picture 3" descr="logo-iiec-light.png"/>
+          <p:cNvPicPr>
+            <a:picLocks noChangeAspect="1"/>
+          </p:cNvPicPr>
+          <p:nvPr/>
+        </p:nvPicPr>
+        <p:blipFill>
+          <a:blip r:embed="rId3"/>
+          <a:stretch>
+            <a:fillRect/>
+          </a:stretch>
+        </p:blipFill>
+        <p:spPr>
+          <a:xfrm>
+            <a:off x="10241280" y="320040"/>
+            <a:ext cx="1497850" cy="566928"/>
+          </a:xfrm>
+          <a:prstGeom prst="rect">
+            <a:avLst/>
+          </a:prstGeom>
+        </p:spPr>
+      </p:pic>
+      <p:sp>
+        <p:nvSpPr>
+          <p:cNvPr id="5" name="Rectangle 4"/>
           <p:cNvSpPr/>
           <p:nvPr/>
         </p:nvSpPr>
         <p:spPr>
           <a:xfrm>
-            <a:off x="365760" y="274320"/>
-            <a:ext cx="1463040" cy="777240"/>
-          </a:xfrm>
-          <a:prstGeom prst="ellipse">
-            <a:avLst/>
-          </a:prstGeom>
-          <a:noFill/>
-          <a:ln w="31750">
-            <a:solidFill>
-              <a:srgbClr val="19E3F5"/>
-            </a:solidFill>
+            <a:off x="0" y="6355080"/>
+            <a:ext cx="12191695" cy="502920"/>
+          </a:xfrm>
+          <a:prstGeom prst="rect">
+            <a:avLst/>
+          </a:prstGeom>
+          <a:solidFill>
+            <a:srgbClr val="19E3F5"/>
+          </a:solidFill>
+          <a:ln>
+            <a:noFill/>
           </a:ln>
           <a:effectLst/>
         </p:spPr>
@@ -4768,32 +4692,23 @@
           </a:fontRef>
         </p:style>
         <p:txBody>
-          <a:bodyPr rtlCol="0" anchor="ctr" wrap="square"/>
+          <a:bodyPr rtlCol="0" anchor="ctr"/>
           <a:lstStyle/>
           <a:p>
             <a:pPr algn="ctr"/>
-            <a:r>
-              <a:rPr sz="1200" b="0">
-                <a:solidFill>
-                  <a:srgbClr val="000000"/>
-                </a:solidFill>
-                <a:latin typeface="Arial"/>
-              </a:rPr>
-              <a:t>Your Team Name</a:t>
-            </a:r>
-          </a:p>
-        </p:txBody>
-      </p:sp>
-      <p:sp>
-        <p:nvSpPr>
-          <p:cNvPr id="3" name="TextBox 2"/>
+          </a:p>
+        </p:txBody>
+      </p:sp>
+      <p:sp>
+        <p:nvSpPr>
+          <p:cNvPr id="6" name="TextBox 5"/>
           <p:cNvSpPr txBox="1"/>
           <p:nvPr/>
         </p:nvSpPr>
         <p:spPr>
           <a:xfrm>
-            <a:off x="1920240" y="228600"/>
-            <a:ext cx="7406640" cy="868680"/>
+            <a:off x="0" y="6355080"/>
+            <a:ext cx="12191695" cy="502920"/>
           </a:xfrm>
           <a:prstGeom prst="rect">
             <a:avLst/>
@@ -4808,106 +4723,14 @@
           <a:p>
             <a:pPr algn="ctr"/>
             <a:r>
-              <a:rPr sz="3000" b="0">
-                <a:solidFill>
-                  <a:srgbClr val="000000"/>
-                </a:solidFill>
-                <a:latin typeface="Arial Black"/>
-              </a:rPr>
-              <a:t>ML MODEL</a:t>
-            </a:r>
-          </a:p>
-        </p:txBody>
-      </p:sp>
-      <p:pic>
-        <p:nvPicPr>
-          <p:cNvPr id="4" name="Picture 3" descr="logo-dsc-light.png"/>
-          <p:cNvPicPr>
-            <a:picLocks noChangeAspect="1"/>
-          </p:cNvPicPr>
-          <p:nvPr/>
-        </p:nvPicPr>
-        <p:blipFill>
-          <a:blip r:embed="rId2"/>
-          <a:stretch>
-            <a:fillRect/>
-          </a:stretch>
-        </p:blipFill>
-        <p:spPr>
-          <a:xfrm>
-            <a:off x="9326880" y="182880"/>
-            <a:ext cx="1087459" cy="868680"/>
-          </a:xfrm>
-          <a:prstGeom prst="rect">
-            <a:avLst/>
-          </a:prstGeom>
-        </p:spPr>
-      </p:pic>
-      <p:pic>
-        <p:nvPicPr>
-          <p:cNvPr id="5" name="Picture 4" descr="logo-iiec-light.png"/>
-          <p:cNvPicPr>
-            <a:picLocks noChangeAspect="1"/>
-          </p:cNvPicPr>
-          <p:nvPr/>
-        </p:nvPicPr>
-        <p:blipFill>
-          <a:blip r:embed="rId3"/>
-          <a:stretch>
-            <a:fillRect/>
-          </a:stretch>
-        </p:blipFill>
-        <p:spPr>
-          <a:xfrm>
-            <a:off x="10698480" y="384048"/>
-            <a:ext cx="1328738" cy="502920"/>
-          </a:xfrm>
-          <a:prstGeom prst="rect">
-            <a:avLst/>
-          </a:prstGeom>
-        </p:spPr>
-      </p:pic>
-      <p:sp>
-        <p:nvSpPr>
-          <p:cNvPr id="6" name="Rectangle 5"/>
-          <p:cNvSpPr/>
-          <p:nvPr/>
-        </p:nvSpPr>
-        <p:spPr>
-          <a:xfrm>
-            <a:off x="0" y="6355080"/>
-            <a:ext cx="12191695" cy="502920"/>
-          </a:xfrm>
-          <a:prstGeom prst="rect">
-            <a:avLst/>
-          </a:prstGeom>
-          <a:solidFill>
-            <a:srgbClr val="19E3F5"/>
-          </a:solidFill>
-          <a:ln>
-            <a:noFill/>
-          </a:ln>
-          <a:effectLst/>
-        </p:spPr>
-        <p:style>
-          <a:lnRef idx="1">
-            <a:schemeClr val="accent1"/>
-          </a:lnRef>
-          <a:fillRef idx="3">
-            <a:schemeClr val="accent1"/>
-          </a:fillRef>
-          <a:effectRef idx="2">
-            <a:schemeClr val="accent1"/>
-          </a:effectRef>
-          <a:fontRef idx="minor">
-            <a:schemeClr val="lt1"/>
-          </a:fontRef>
-        </p:style>
-        <p:txBody>
-          <a:bodyPr rtlCol="0" anchor="ctr"/>
-          <a:lstStyle/>
-          <a:p>
-            <a:pPr algn="ctr"/>
+              <a:rPr sz="1200" b="1">
+                <a:solidFill>
+                  <a:srgbClr val="000000"/>
+                </a:solidFill>
+                <a:latin typeface="Arial"/>
+              </a:rPr>
+              <a:t>DATATHON 2026  ·  Round 1 Idea Submission – Template</a:t>
+            </a:r>
           </a:p>
         </p:txBody>
       </p:sp>
@@ -4919,8 +4742,8 @@
         </p:nvSpPr>
         <p:spPr>
           <a:xfrm>
-            <a:off x="0" y="6355080"/>
-            <a:ext cx="12191695" cy="502920"/>
+            <a:off x="10881360" y="6355080"/>
+            <a:ext cx="1005840" cy="502920"/>
           </a:xfrm>
           <a:prstGeom prst="rect">
             <a:avLst/>
@@ -4933,15 +4756,15 @@
           </a:bodyPr>
           <a:lstStyle/>
           <a:p>
-            <a:pPr algn="ctr"/>
-            <a:r>
-              <a:rPr sz="1200" b="1">
+            <a:pPr algn="r"/>
+            <a:r>
+              <a:rPr sz="1300" b="1">
                 <a:solidFill>
                   <a:srgbClr val="000000"/>
                 </a:solidFill>
                 <a:latin typeface="Arial"/>
               </a:rPr>
-              <a:t>DATATHON 2026  ·  Round 1 Idea Submission – Template</a:t>
+              <a:t>5</a:t>
             </a:r>
           </a:p>
         </p:txBody>
@@ -4949,41 +4772,6 @@
       <p:sp>
         <p:nvSpPr>
           <p:cNvPr id="8" name="TextBox 7"/>
-          <p:cNvSpPr txBox="1"/>
-          <p:nvPr/>
-        </p:nvSpPr>
-        <p:spPr>
-          <a:xfrm>
-            <a:off x="10881360" y="6355080"/>
-            <a:ext cx="1005840" cy="502920"/>
-          </a:xfrm>
-          <a:prstGeom prst="rect">
-            <a:avLst/>
-          </a:prstGeom>
-          <a:noFill/>
-        </p:spPr>
-        <p:txBody>
-          <a:bodyPr wrap="square" anchor="ctr">
-            <a:spAutoFit/>
-          </a:bodyPr>
-          <a:lstStyle/>
-          <a:p>
-            <a:pPr algn="r"/>
-            <a:r>
-              <a:rPr sz="1300" b="1">
-                <a:solidFill>
-                  <a:srgbClr val="000000"/>
-                </a:solidFill>
-                <a:latin typeface="Arial"/>
-              </a:rPr>
-              <a:t>5</a:t>
-            </a:r>
-          </a:p>
-        </p:txBody>
-      </p:sp>
-      <p:sp>
-        <p:nvSpPr>
-          <p:cNvPr id="9" name="TextBox 8"/>
           <p:cNvSpPr txBox="1"/>
           <p:nvPr/>
         </p:nvSpPr>
@@ -5027,7 +4815,7 @@
       </p:sp>
       <p:sp>
         <p:nvSpPr>
-          <p:cNvPr id="10" name="TextBox 9"/>
+          <p:cNvPr id="9" name="TextBox 8"/>
           <p:cNvSpPr txBox="1"/>
           <p:nvPr/>
         </p:nvSpPr>
@@ -5130,23 +4918,106 @@
       <p:grpSpPr/>
       <p:sp>
         <p:nvSpPr>
-          <p:cNvPr id="2" name="Oval 1"/>
+          <p:cNvPr id="2" name="TextBox 1"/>
+          <p:cNvSpPr txBox="1"/>
+          <p:nvPr/>
+        </p:nvSpPr>
+        <p:spPr>
+          <a:xfrm>
+            <a:off x="1783080" y="228600"/>
+            <a:ext cx="8595360" cy="868680"/>
+          </a:xfrm>
+          <a:prstGeom prst="rect">
+            <a:avLst/>
+          </a:prstGeom>
+          <a:noFill/>
+        </p:spPr>
+        <p:txBody>
+          <a:bodyPr wrap="square" anchor="ctr">
+            <a:spAutoFit/>
+          </a:bodyPr>
+          <a:lstStyle/>
+          <a:p>
+            <a:pPr algn="ctr"/>
+            <a:r>
+              <a:rPr sz="3000" b="0">
+                <a:solidFill>
+                  <a:srgbClr val="000000"/>
+                </a:solidFill>
+                <a:latin typeface="Arial Black"/>
+              </a:rPr>
+              <a:t>BASE PROTOTYPE &amp; MVP</a:t>
+            </a:r>
+          </a:p>
+        </p:txBody>
+      </p:sp>
+      <p:pic>
+        <p:nvPicPr>
+          <p:cNvPr id="3" name="Picture 2" descr="logo-dsc-light.png"/>
+          <p:cNvPicPr>
+            <a:picLocks noChangeAspect="1"/>
+          </p:cNvPicPr>
+          <p:nvPr/>
+        </p:nvPicPr>
+        <p:blipFill>
+          <a:blip r:embed="rId2"/>
+          <a:stretch>
+            <a:fillRect/>
+          </a:stretch>
+        </p:blipFill>
+        <p:spPr>
+          <a:xfrm>
+            <a:off x="411480" y="137160"/>
+            <a:ext cx="1144693" cy="914400"/>
+          </a:xfrm>
+          <a:prstGeom prst="rect">
+            <a:avLst/>
+          </a:prstGeom>
+        </p:spPr>
+      </p:pic>
+      <p:pic>
+        <p:nvPicPr>
+          <p:cNvPr id="4" name="Picture 3" descr="logo-iiec-light.png"/>
+          <p:cNvPicPr>
+            <a:picLocks noChangeAspect="1"/>
+          </p:cNvPicPr>
+          <p:nvPr/>
+        </p:nvPicPr>
+        <p:blipFill>
+          <a:blip r:embed="rId3"/>
+          <a:stretch>
+            <a:fillRect/>
+          </a:stretch>
+        </p:blipFill>
+        <p:spPr>
+          <a:xfrm>
+            <a:off x="10241280" y="320040"/>
+            <a:ext cx="1497850" cy="566928"/>
+          </a:xfrm>
+          <a:prstGeom prst="rect">
+            <a:avLst/>
+          </a:prstGeom>
+        </p:spPr>
+      </p:pic>
+      <p:sp>
+        <p:nvSpPr>
+          <p:cNvPr id="5" name="Rectangle 4"/>
           <p:cNvSpPr/>
           <p:nvPr/>
         </p:nvSpPr>
         <p:spPr>
           <a:xfrm>
-            <a:off x="365760" y="274320"/>
-            <a:ext cx="1463040" cy="777240"/>
-          </a:xfrm>
-          <a:prstGeom prst="ellipse">
-            <a:avLst/>
-          </a:prstGeom>
-          <a:noFill/>
-          <a:ln w="31750">
-            <a:solidFill>
-              <a:srgbClr val="19E3F5"/>
-            </a:solidFill>
+            <a:off x="0" y="6355080"/>
+            <a:ext cx="12191695" cy="502920"/>
+          </a:xfrm>
+          <a:prstGeom prst="rect">
+            <a:avLst/>
+          </a:prstGeom>
+          <a:solidFill>
+            <a:srgbClr val="19E3F5"/>
+          </a:solidFill>
+          <a:ln>
+            <a:noFill/>
           </a:ln>
           <a:effectLst/>
         </p:spPr>
@@ -5165,32 +5036,23 @@
           </a:fontRef>
         </p:style>
         <p:txBody>
-          <a:bodyPr rtlCol="0" anchor="ctr" wrap="square"/>
+          <a:bodyPr rtlCol="0" anchor="ctr"/>
           <a:lstStyle/>
           <a:p>
             <a:pPr algn="ctr"/>
-            <a:r>
-              <a:rPr sz="1200" b="0">
-                <a:solidFill>
-                  <a:srgbClr val="000000"/>
-                </a:solidFill>
-                <a:latin typeface="Arial"/>
-              </a:rPr>
-              <a:t>Your Team Name</a:t>
-            </a:r>
-          </a:p>
-        </p:txBody>
-      </p:sp>
-      <p:sp>
-        <p:nvSpPr>
-          <p:cNvPr id="3" name="TextBox 2"/>
+          </a:p>
+        </p:txBody>
+      </p:sp>
+      <p:sp>
+        <p:nvSpPr>
+          <p:cNvPr id="6" name="TextBox 5"/>
           <p:cNvSpPr txBox="1"/>
           <p:nvPr/>
         </p:nvSpPr>
         <p:spPr>
           <a:xfrm>
-            <a:off x="1920240" y="228600"/>
-            <a:ext cx="7406640" cy="868680"/>
+            <a:off x="0" y="6355080"/>
+            <a:ext cx="12191695" cy="502920"/>
           </a:xfrm>
           <a:prstGeom prst="rect">
             <a:avLst/>
@@ -5205,106 +5067,14 @@
           <a:p>
             <a:pPr algn="ctr"/>
             <a:r>
-              <a:rPr sz="3000" b="0">
-                <a:solidFill>
-                  <a:srgbClr val="000000"/>
-                </a:solidFill>
-                <a:latin typeface="Arial Black"/>
-              </a:rPr>
-              <a:t>BASE PROTOTYPE &amp; MVP</a:t>
-            </a:r>
-          </a:p>
-        </p:txBody>
-      </p:sp>
-      <p:pic>
-        <p:nvPicPr>
-          <p:cNvPr id="4" name="Picture 3" descr="logo-dsc-light.png"/>
-          <p:cNvPicPr>
-            <a:picLocks noChangeAspect="1"/>
-          </p:cNvPicPr>
-          <p:nvPr/>
-        </p:nvPicPr>
-        <p:blipFill>
-          <a:blip r:embed="rId2"/>
-          <a:stretch>
-            <a:fillRect/>
-          </a:stretch>
-        </p:blipFill>
-        <p:spPr>
-          <a:xfrm>
-            <a:off x="9326880" y="182880"/>
-            <a:ext cx="1087459" cy="868680"/>
-          </a:xfrm>
-          <a:prstGeom prst="rect">
-            <a:avLst/>
-          </a:prstGeom>
-        </p:spPr>
-      </p:pic>
-      <p:pic>
-        <p:nvPicPr>
-          <p:cNvPr id="5" name="Picture 4" descr="logo-iiec-light.png"/>
-          <p:cNvPicPr>
-            <a:picLocks noChangeAspect="1"/>
-          </p:cNvPicPr>
-          <p:nvPr/>
-        </p:nvPicPr>
-        <p:blipFill>
-          <a:blip r:embed="rId3"/>
-          <a:stretch>
-            <a:fillRect/>
-          </a:stretch>
-        </p:blipFill>
-        <p:spPr>
-          <a:xfrm>
-            <a:off x="10698480" y="384048"/>
-            <a:ext cx="1328738" cy="502920"/>
-          </a:xfrm>
-          <a:prstGeom prst="rect">
-            <a:avLst/>
-          </a:prstGeom>
-        </p:spPr>
-      </p:pic>
-      <p:sp>
-        <p:nvSpPr>
-          <p:cNvPr id="6" name="Rectangle 5"/>
-          <p:cNvSpPr/>
-          <p:nvPr/>
-        </p:nvSpPr>
-        <p:spPr>
-          <a:xfrm>
-            <a:off x="0" y="6355080"/>
-            <a:ext cx="12191695" cy="502920"/>
-          </a:xfrm>
-          <a:prstGeom prst="rect">
-            <a:avLst/>
-          </a:prstGeom>
-          <a:solidFill>
-            <a:srgbClr val="19E3F5"/>
-          </a:solidFill>
-          <a:ln>
-            <a:noFill/>
-          </a:ln>
-          <a:effectLst/>
-        </p:spPr>
-        <p:style>
-          <a:lnRef idx="1">
-            <a:schemeClr val="accent1"/>
-          </a:lnRef>
-          <a:fillRef idx="3">
-            <a:schemeClr val="accent1"/>
-          </a:fillRef>
-          <a:effectRef idx="2">
-            <a:schemeClr val="accent1"/>
-          </a:effectRef>
-          <a:fontRef idx="minor">
-            <a:schemeClr val="lt1"/>
-          </a:fontRef>
-        </p:style>
-        <p:txBody>
-          <a:bodyPr rtlCol="0" anchor="ctr"/>
-          <a:lstStyle/>
-          <a:p>
-            <a:pPr algn="ctr"/>
+              <a:rPr sz="1200" b="1">
+                <a:solidFill>
+                  <a:srgbClr val="000000"/>
+                </a:solidFill>
+                <a:latin typeface="Arial"/>
+              </a:rPr>
+              <a:t>DATATHON 2026  ·  Round 1 Idea Submission – Template</a:t>
+            </a:r>
           </a:p>
         </p:txBody>
       </p:sp>
@@ -5316,8 +5086,8 @@
         </p:nvSpPr>
         <p:spPr>
           <a:xfrm>
-            <a:off x="0" y="6355080"/>
-            <a:ext cx="12191695" cy="502920"/>
+            <a:off x="10881360" y="6355080"/>
+            <a:ext cx="1005840" cy="502920"/>
           </a:xfrm>
           <a:prstGeom prst="rect">
             <a:avLst/>
@@ -5330,15 +5100,15 @@
           </a:bodyPr>
           <a:lstStyle/>
           <a:p>
-            <a:pPr algn="ctr"/>
-            <a:r>
-              <a:rPr sz="1200" b="1">
+            <a:pPr algn="r"/>
+            <a:r>
+              <a:rPr sz="1300" b="1">
                 <a:solidFill>
                   <a:srgbClr val="000000"/>
                 </a:solidFill>
                 <a:latin typeface="Arial"/>
               </a:rPr>
-              <a:t>DATATHON 2026  ·  Round 1 Idea Submission – Template</a:t>
+              <a:t>6</a:t>
             </a:r>
           </a:p>
         </p:txBody>
@@ -5346,41 +5116,6 @@
       <p:sp>
         <p:nvSpPr>
           <p:cNvPr id="8" name="TextBox 7"/>
-          <p:cNvSpPr txBox="1"/>
-          <p:nvPr/>
-        </p:nvSpPr>
-        <p:spPr>
-          <a:xfrm>
-            <a:off x="10881360" y="6355080"/>
-            <a:ext cx="1005840" cy="502920"/>
-          </a:xfrm>
-          <a:prstGeom prst="rect">
-            <a:avLst/>
-          </a:prstGeom>
-          <a:noFill/>
-        </p:spPr>
-        <p:txBody>
-          <a:bodyPr wrap="square" anchor="ctr">
-            <a:spAutoFit/>
-          </a:bodyPr>
-          <a:lstStyle/>
-          <a:p>
-            <a:pPr algn="r"/>
-            <a:r>
-              <a:rPr sz="1300" b="1">
-                <a:solidFill>
-                  <a:srgbClr val="000000"/>
-                </a:solidFill>
-                <a:latin typeface="Arial"/>
-              </a:rPr>
-              <a:t>6</a:t>
-            </a:r>
-          </a:p>
-        </p:txBody>
-      </p:sp>
-      <p:sp>
-        <p:nvSpPr>
-          <p:cNvPr id="9" name="TextBox 8"/>
           <p:cNvSpPr txBox="1"/>
           <p:nvPr/>
         </p:nvSpPr>
@@ -5424,7 +5159,7 @@
       </p:sp>
       <p:sp>
         <p:nvSpPr>
-          <p:cNvPr id="10" name="TextBox 9"/>
+          <p:cNvPr id="9" name="TextBox 8"/>
           <p:cNvSpPr txBox="1"/>
           <p:nvPr/>
         </p:nvSpPr>
@@ -5465,7 +5200,7 @@
       </p:sp>
       <p:sp>
         <p:nvSpPr>
-          <p:cNvPr id="11" name="TextBox 10"/>
+          <p:cNvPr id="10" name="TextBox 9"/>
           <p:cNvSpPr txBox="1"/>
           <p:nvPr/>
         </p:nvSpPr>
@@ -5518,7 +5253,7 @@
       </p:sp>
       <p:sp>
         <p:nvSpPr>
-          <p:cNvPr id="12" name="TextBox 11"/>
+          <p:cNvPr id="11" name="TextBox 10"/>
           <p:cNvSpPr txBox="1"/>
           <p:nvPr/>
         </p:nvSpPr>
@@ -5603,23 +5338,106 @@
       <p:grpSpPr/>
       <p:sp>
         <p:nvSpPr>
-          <p:cNvPr id="2" name="Oval 1"/>
+          <p:cNvPr id="2" name="TextBox 1"/>
+          <p:cNvSpPr txBox="1"/>
+          <p:nvPr/>
+        </p:nvSpPr>
+        <p:spPr>
+          <a:xfrm>
+            <a:off x="1783080" y="228600"/>
+            <a:ext cx="8595360" cy="868680"/>
+          </a:xfrm>
+          <a:prstGeom prst="rect">
+            <a:avLst/>
+          </a:prstGeom>
+          <a:noFill/>
+        </p:spPr>
+        <p:txBody>
+          <a:bodyPr wrap="square" anchor="ctr">
+            <a:spAutoFit/>
+          </a:bodyPr>
+          <a:lstStyle/>
+          <a:p>
+            <a:pPr algn="ctr"/>
+            <a:r>
+              <a:rPr sz="3000" b="0">
+                <a:solidFill>
+                  <a:srgbClr val="000000"/>
+                </a:solidFill>
+                <a:latin typeface="Arial Black"/>
+              </a:rPr>
+              <a:t>TECHNICAL APPROACH</a:t>
+            </a:r>
+          </a:p>
+        </p:txBody>
+      </p:sp>
+      <p:pic>
+        <p:nvPicPr>
+          <p:cNvPr id="3" name="Picture 2" descr="logo-dsc-light.png"/>
+          <p:cNvPicPr>
+            <a:picLocks noChangeAspect="1"/>
+          </p:cNvPicPr>
+          <p:nvPr/>
+        </p:nvPicPr>
+        <p:blipFill>
+          <a:blip r:embed="rId2"/>
+          <a:stretch>
+            <a:fillRect/>
+          </a:stretch>
+        </p:blipFill>
+        <p:spPr>
+          <a:xfrm>
+            <a:off x="411480" y="137160"/>
+            <a:ext cx="1144693" cy="914400"/>
+          </a:xfrm>
+          <a:prstGeom prst="rect">
+            <a:avLst/>
+          </a:prstGeom>
+        </p:spPr>
+      </p:pic>
+      <p:pic>
+        <p:nvPicPr>
+          <p:cNvPr id="4" name="Picture 3" descr="logo-iiec-light.png"/>
+          <p:cNvPicPr>
+            <a:picLocks noChangeAspect="1"/>
+          </p:cNvPicPr>
+          <p:nvPr/>
+        </p:nvPicPr>
+        <p:blipFill>
+          <a:blip r:embed="rId3"/>
+          <a:stretch>
+            <a:fillRect/>
+          </a:stretch>
+        </p:blipFill>
+        <p:spPr>
+          <a:xfrm>
+            <a:off x="10241280" y="320040"/>
+            <a:ext cx="1497850" cy="566928"/>
+          </a:xfrm>
+          <a:prstGeom prst="rect">
+            <a:avLst/>
+          </a:prstGeom>
+        </p:spPr>
+      </p:pic>
+      <p:sp>
+        <p:nvSpPr>
+          <p:cNvPr id="5" name="Rectangle 4"/>
           <p:cNvSpPr/>
           <p:nvPr/>
         </p:nvSpPr>
         <p:spPr>
           <a:xfrm>
-            <a:off x="365760" y="274320"/>
-            <a:ext cx="1463040" cy="777240"/>
-          </a:xfrm>
-          <a:prstGeom prst="ellipse">
-            <a:avLst/>
-          </a:prstGeom>
-          <a:noFill/>
-          <a:ln w="31750">
-            <a:solidFill>
-              <a:srgbClr val="19E3F5"/>
-            </a:solidFill>
+            <a:off x="0" y="6355080"/>
+            <a:ext cx="12191695" cy="502920"/>
+          </a:xfrm>
+          <a:prstGeom prst="rect">
+            <a:avLst/>
+          </a:prstGeom>
+          <a:solidFill>
+            <a:srgbClr val="19E3F5"/>
+          </a:solidFill>
+          <a:ln>
+            <a:noFill/>
           </a:ln>
           <a:effectLst/>
         </p:spPr>
@@ -5638,32 +5456,23 @@
           </a:fontRef>
         </p:style>
         <p:txBody>
-          <a:bodyPr rtlCol="0" anchor="ctr" wrap="square"/>
+          <a:bodyPr rtlCol="0" anchor="ctr"/>
           <a:lstStyle/>
           <a:p>
             <a:pPr algn="ctr"/>
-            <a:r>
-              <a:rPr sz="1200" b="0">
-                <a:solidFill>
-                  <a:srgbClr val="000000"/>
-                </a:solidFill>
-                <a:latin typeface="Arial"/>
-              </a:rPr>
-              <a:t>Your Team Name</a:t>
-            </a:r>
-          </a:p>
-        </p:txBody>
-      </p:sp>
-      <p:sp>
-        <p:nvSpPr>
-          <p:cNvPr id="3" name="TextBox 2"/>
+          </a:p>
+        </p:txBody>
+      </p:sp>
+      <p:sp>
+        <p:nvSpPr>
+          <p:cNvPr id="6" name="TextBox 5"/>
           <p:cNvSpPr txBox="1"/>
           <p:nvPr/>
         </p:nvSpPr>
         <p:spPr>
           <a:xfrm>
-            <a:off x="1920240" y="228600"/>
-            <a:ext cx="7406640" cy="868680"/>
+            <a:off x="0" y="6355080"/>
+            <a:ext cx="12191695" cy="502920"/>
           </a:xfrm>
           <a:prstGeom prst="rect">
             <a:avLst/>
@@ -5678,106 +5487,14 @@
           <a:p>
             <a:pPr algn="ctr"/>
             <a:r>
-              <a:rPr sz="3000" b="0">
-                <a:solidFill>
-                  <a:srgbClr val="000000"/>
-                </a:solidFill>
-                <a:latin typeface="Arial Black"/>
-              </a:rPr>
-              <a:t>TECHNICAL APPROACH</a:t>
-            </a:r>
-          </a:p>
-        </p:txBody>
-      </p:sp>
-      <p:pic>
-        <p:nvPicPr>
-          <p:cNvPr id="4" name="Picture 3" descr="logo-dsc-light.png"/>
-          <p:cNvPicPr>
-            <a:picLocks noChangeAspect="1"/>
-          </p:cNvPicPr>
-          <p:nvPr/>
-        </p:nvPicPr>
-        <p:blipFill>
-          <a:blip r:embed="rId2"/>
-          <a:stretch>
-            <a:fillRect/>
-          </a:stretch>
-        </p:blipFill>
-        <p:spPr>
-          <a:xfrm>
-            <a:off x="9326880" y="182880"/>
-            <a:ext cx="1087459" cy="868680"/>
-          </a:xfrm>
-          <a:prstGeom prst="rect">
-            <a:avLst/>
-          </a:prstGeom>
-        </p:spPr>
-      </p:pic>
-      <p:pic>
-        <p:nvPicPr>
-          <p:cNvPr id="5" name="Picture 4" descr="logo-iiec-light.png"/>
-          <p:cNvPicPr>
-            <a:picLocks noChangeAspect="1"/>
-          </p:cNvPicPr>
-          <p:nvPr/>
-        </p:nvPicPr>
-        <p:blipFill>
-          <a:blip r:embed="rId3"/>
-          <a:stretch>
-            <a:fillRect/>
-          </a:stretch>
-        </p:blipFill>
-        <p:spPr>
-          <a:xfrm>
-            <a:off x="10698480" y="384048"/>
-            <a:ext cx="1328738" cy="502920"/>
-          </a:xfrm>
-          <a:prstGeom prst="rect">
-            <a:avLst/>
-          </a:prstGeom>
-        </p:spPr>
-      </p:pic>
-      <p:sp>
-        <p:nvSpPr>
-          <p:cNvPr id="6" name="Rectangle 5"/>
-          <p:cNvSpPr/>
-          <p:nvPr/>
-        </p:nvSpPr>
-        <p:spPr>
-          <a:xfrm>
-            <a:off x="0" y="6355080"/>
-            <a:ext cx="12191695" cy="502920"/>
-          </a:xfrm>
-          <a:prstGeom prst="rect">
-            <a:avLst/>
-          </a:prstGeom>
-          <a:solidFill>
-            <a:srgbClr val="19E3F5"/>
-          </a:solidFill>
-          <a:ln>
-            <a:noFill/>
-          </a:ln>
-          <a:effectLst/>
-        </p:spPr>
-        <p:style>
-          <a:lnRef idx="1">
-            <a:schemeClr val="accent1"/>
-          </a:lnRef>
-          <a:fillRef idx="3">
-            <a:schemeClr val="accent1"/>
-          </a:fillRef>
-          <a:effectRef idx="2">
-            <a:schemeClr val="accent1"/>
-          </a:effectRef>
-          <a:fontRef idx="minor">
-            <a:schemeClr val="lt1"/>
-          </a:fontRef>
-        </p:style>
-        <p:txBody>
-          <a:bodyPr rtlCol="0" anchor="ctr"/>
-          <a:lstStyle/>
-          <a:p>
-            <a:pPr algn="ctr"/>
+              <a:rPr sz="1200" b="1">
+                <a:solidFill>
+                  <a:srgbClr val="000000"/>
+                </a:solidFill>
+                <a:latin typeface="Arial"/>
+              </a:rPr>
+              <a:t>DATATHON 2026  ·  Round 1 Idea Submission – Template</a:t>
+            </a:r>
           </a:p>
         </p:txBody>
       </p:sp>
@@ -5789,8 +5506,8 @@
         </p:nvSpPr>
         <p:spPr>
           <a:xfrm>
-            <a:off x="0" y="6355080"/>
-            <a:ext cx="12191695" cy="502920"/>
+            <a:off x="10881360" y="6355080"/>
+            <a:ext cx="1005840" cy="502920"/>
           </a:xfrm>
           <a:prstGeom prst="rect">
             <a:avLst/>
@@ -5803,15 +5520,15 @@
           </a:bodyPr>
           <a:lstStyle/>
           <a:p>
-            <a:pPr algn="ctr"/>
-            <a:r>
-              <a:rPr sz="1200" b="1">
+            <a:pPr algn="r"/>
+            <a:r>
+              <a:rPr sz="1300" b="1">
                 <a:solidFill>
                   <a:srgbClr val="000000"/>
                 </a:solidFill>
                 <a:latin typeface="Arial"/>
               </a:rPr>
-              <a:t>DATATHON 2026  ·  Round 1 Idea Submission – Template</a:t>
+              <a:t>7</a:t>
             </a:r>
           </a:p>
         </p:txBody>
@@ -5819,41 +5536,6 @@
       <p:sp>
         <p:nvSpPr>
           <p:cNvPr id="8" name="TextBox 7"/>
-          <p:cNvSpPr txBox="1"/>
-          <p:nvPr/>
-        </p:nvSpPr>
-        <p:spPr>
-          <a:xfrm>
-            <a:off x="10881360" y="6355080"/>
-            <a:ext cx="1005840" cy="502920"/>
-          </a:xfrm>
-          <a:prstGeom prst="rect">
-            <a:avLst/>
-          </a:prstGeom>
-          <a:noFill/>
-        </p:spPr>
-        <p:txBody>
-          <a:bodyPr wrap="square" anchor="ctr">
-            <a:spAutoFit/>
-          </a:bodyPr>
-          <a:lstStyle/>
-          <a:p>
-            <a:pPr algn="r"/>
-            <a:r>
-              <a:rPr sz="1300" b="1">
-                <a:solidFill>
-                  <a:srgbClr val="000000"/>
-                </a:solidFill>
-                <a:latin typeface="Arial"/>
-              </a:rPr>
-              <a:t>7</a:t>
-            </a:r>
-          </a:p>
-        </p:txBody>
-      </p:sp>
-      <p:sp>
-        <p:nvSpPr>
-          <p:cNvPr id="9" name="TextBox 8"/>
           <p:cNvSpPr txBox="1"/>
           <p:nvPr/>
         </p:nvSpPr>
@@ -5897,7 +5579,7 @@
       </p:sp>
       <p:sp>
         <p:nvSpPr>
-          <p:cNvPr id="10" name="TextBox 9"/>
+          <p:cNvPr id="9" name="TextBox 8"/>
           <p:cNvSpPr txBox="1"/>
           <p:nvPr/>
         </p:nvSpPr>
@@ -5982,23 +5664,106 @@
       <p:grpSpPr/>
       <p:sp>
         <p:nvSpPr>
-          <p:cNvPr id="2" name="Oval 1"/>
+          <p:cNvPr id="2" name="TextBox 1"/>
+          <p:cNvSpPr txBox="1"/>
+          <p:nvPr/>
+        </p:nvSpPr>
+        <p:spPr>
+          <a:xfrm>
+            <a:off x="1783080" y="228600"/>
+            <a:ext cx="8595360" cy="868680"/>
+          </a:xfrm>
+          <a:prstGeom prst="rect">
+            <a:avLst/>
+          </a:prstGeom>
+          <a:noFill/>
+        </p:spPr>
+        <p:txBody>
+          <a:bodyPr wrap="square" anchor="ctr">
+            <a:spAutoFit/>
+          </a:bodyPr>
+          <a:lstStyle/>
+          <a:p>
+            <a:pPr algn="ctr"/>
+            <a:r>
+              <a:rPr sz="3000" b="0">
+                <a:solidFill>
+                  <a:srgbClr val="000000"/>
+                </a:solidFill>
+                <a:latin typeface="Arial Black"/>
+              </a:rPr>
+              <a:t>FEASIBILITY, IMPACT &amp; NEXT STEPS</a:t>
+            </a:r>
+          </a:p>
+        </p:txBody>
+      </p:sp>
+      <p:pic>
+        <p:nvPicPr>
+          <p:cNvPr id="3" name="Picture 2" descr="logo-dsc-light.png"/>
+          <p:cNvPicPr>
+            <a:picLocks noChangeAspect="1"/>
+          </p:cNvPicPr>
+          <p:nvPr/>
+        </p:nvPicPr>
+        <p:blipFill>
+          <a:blip r:embed="rId2"/>
+          <a:stretch>
+            <a:fillRect/>
+          </a:stretch>
+        </p:blipFill>
+        <p:spPr>
+          <a:xfrm>
+            <a:off x="411480" y="137160"/>
+            <a:ext cx="1144693" cy="914400"/>
+          </a:xfrm>
+          <a:prstGeom prst="rect">
+            <a:avLst/>
+          </a:prstGeom>
+        </p:spPr>
+      </p:pic>
+      <p:pic>
+        <p:nvPicPr>
+          <p:cNvPr id="4" name="Picture 3" descr="logo-iiec-light.png"/>
+          <p:cNvPicPr>
+            <a:picLocks noChangeAspect="1"/>
+          </p:cNvPicPr>
+          <p:nvPr/>
+        </p:nvPicPr>
+        <p:blipFill>
+          <a:blip r:embed="rId3"/>
+          <a:stretch>
+            <a:fillRect/>
+          </a:stretch>
+        </p:blipFill>
+        <p:spPr>
+          <a:xfrm>
+            <a:off x="10241280" y="320040"/>
+            <a:ext cx="1497850" cy="566928"/>
+          </a:xfrm>
+          <a:prstGeom prst="rect">
+            <a:avLst/>
+          </a:prstGeom>
+        </p:spPr>
+      </p:pic>
+      <p:sp>
+        <p:nvSpPr>
+          <p:cNvPr id="5" name="Rectangle 4"/>
           <p:cNvSpPr/>
           <p:nvPr/>
         </p:nvSpPr>
         <p:spPr>
           <a:xfrm>
-            <a:off x="365760" y="274320"/>
-            <a:ext cx="1463040" cy="777240"/>
-          </a:xfrm>
-          <a:prstGeom prst="ellipse">
-            <a:avLst/>
-          </a:prstGeom>
-          <a:noFill/>
-          <a:ln w="31750">
-            <a:solidFill>
-              <a:srgbClr val="19E3F5"/>
-            </a:solidFill>
+            <a:off x="0" y="6355080"/>
+            <a:ext cx="12191695" cy="502920"/>
+          </a:xfrm>
+          <a:prstGeom prst="rect">
+            <a:avLst/>
+          </a:prstGeom>
+          <a:solidFill>
+            <a:srgbClr val="19E3F5"/>
+          </a:solidFill>
+          <a:ln>
+            <a:noFill/>
           </a:ln>
           <a:effectLst/>
         </p:spPr>
@@ -6017,32 +5782,23 @@
           </a:fontRef>
         </p:style>
         <p:txBody>
-          <a:bodyPr rtlCol="0" anchor="ctr" wrap="square"/>
+          <a:bodyPr rtlCol="0" anchor="ctr"/>
           <a:lstStyle/>
           <a:p>
             <a:pPr algn="ctr"/>
-            <a:r>
-              <a:rPr sz="1200" b="0">
-                <a:solidFill>
-                  <a:srgbClr val="000000"/>
-                </a:solidFill>
-                <a:latin typeface="Arial"/>
-              </a:rPr>
-              <a:t>Your Team Name</a:t>
-            </a:r>
-          </a:p>
-        </p:txBody>
-      </p:sp>
-      <p:sp>
-        <p:nvSpPr>
-          <p:cNvPr id="3" name="TextBox 2"/>
+          </a:p>
+        </p:txBody>
+      </p:sp>
+      <p:sp>
+        <p:nvSpPr>
+          <p:cNvPr id="6" name="TextBox 5"/>
           <p:cNvSpPr txBox="1"/>
           <p:nvPr/>
         </p:nvSpPr>
         <p:spPr>
           <a:xfrm>
-            <a:off x="1920240" y="228600"/>
-            <a:ext cx="7406640" cy="868680"/>
+            <a:off x="0" y="6355080"/>
+            <a:ext cx="12191695" cy="502920"/>
           </a:xfrm>
           <a:prstGeom prst="rect">
             <a:avLst/>
@@ -6057,106 +5813,14 @@
           <a:p>
             <a:pPr algn="ctr"/>
             <a:r>
-              <a:rPr sz="3000" b="0">
-                <a:solidFill>
-                  <a:srgbClr val="000000"/>
-                </a:solidFill>
-                <a:latin typeface="Arial Black"/>
-              </a:rPr>
-              <a:t>FEASIBILITY, IMPACT &amp; NEXT STEPS</a:t>
-            </a:r>
-          </a:p>
-        </p:txBody>
-      </p:sp>
-      <p:pic>
-        <p:nvPicPr>
-          <p:cNvPr id="4" name="Picture 3" descr="logo-dsc-light.png"/>
-          <p:cNvPicPr>
-            <a:picLocks noChangeAspect="1"/>
-          </p:cNvPicPr>
-          <p:nvPr/>
-        </p:nvPicPr>
-        <p:blipFill>
-          <a:blip r:embed="rId2"/>
-          <a:stretch>
-            <a:fillRect/>
-          </a:stretch>
-        </p:blipFill>
-        <p:spPr>
-          <a:xfrm>
-            <a:off x="9326880" y="182880"/>
-            <a:ext cx="1087459" cy="868680"/>
-          </a:xfrm>
-          <a:prstGeom prst="rect">
-            <a:avLst/>
-          </a:prstGeom>
-        </p:spPr>
-      </p:pic>
-      <p:pic>
-        <p:nvPicPr>
-          <p:cNvPr id="5" name="Picture 4" descr="logo-iiec-light.png"/>
-          <p:cNvPicPr>
-            <a:picLocks noChangeAspect="1"/>
-          </p:cNvPicPr>
-          <p:nvPr/>
-        </p:nvPicPr>
-        <p:blipFill>
-          <a:blip r:embed="rId3"/>
-          <a:stretch>
-            <a:fillRect/>
-          </a:stretch>
-        </p:blipFill>
-        <p:spPr>
-          <a:xfrm>
-            <a:off x="10698480" y="384048"/>
-            <a:ext cx="1328738" cy="502920"/>
-          </a:xfrm>
-          <a:prstGeom prst="rect">
-            <a:avLst/>
-          </a:prstGeom>
-        </p:spPr>
-      </p:pic>
-      <p:sp>
-        <p:nvSpPr>
-          <p:cNvPr id="6" name="Rectangle 5"/>
-          <p:cNvSpPr/>
-          <p:nvPr/>
-        </p:nvSpPr>
-        <p:spPr>
-          <a:xfrm>
-            <a:off x="0" y="6355080"/>
-            <a:ext cx="12191695" cy="502920"/>
-          </a:xfrm>
-          <a:prstGeom prst="rect">
-            <a:avLst/>
-          </a:prstGeom>
-          <a:solidFill>
-            <a:srgbClr val="19E3F5"/>
-          </a:solidFill>
-          <a:ln>
-            <a:noFill/>
-          </a:ln>
-          <a:effectLst/>
-        </p:spPr>
-        <p:style>
-          <a:lnRef idx="1">
-            <a:schemeClr val="accent1"/>
-          </a:lnRef>
-          <a:fillRef idx="3">
-            <a:schemeClr val="accent1"/>
-          </a:fillRef>
-          <a:effectRef idx="2">
-            <a:schemeClr val="accent1"/>
-          </a:effectRef>
-          <a:fontRef idx="minor">
-            <a:schemeClr val="lt1"/>
-          </a:fontRef>
-        </p:style>
-        <p:txBody>
-          <a:bodyPr rtlCol="0" anchor="ctr"/>
-          <a:lstStyle/>
-          <a:p>
-            <a:pPr algn="ctr"/>
+              <a:rPr sz="1200" b="1">
+                <a:solidFill>
+                  <a:srgbClr val="000000"/>
+                </a:solidFill>
+                <a:latin typeface="Arial"/>
+              </a:rPr>
+              <a:t>DATATHON 2026  ·  Round 1 Idea Submission – Template</a:t>
+            </a:r>
           </a:p>
         </p:txBody>
       </p:sp>
@@ -6168,8 +5832,8 @@
         </p:nvSpPr>
         <p:spPr>
           <a:xfrm>
-            <a:off x="0" y="6355080"/>
-            <a:ext cx="12191695" cy="502920"/>
+            <a:off x="10881360" y="6355080"/>
+            <a:ext cx="1005840" cy="502920"/>
           </a:xfrm>
           <a:prstGeom prst="rect">
             <a:avLst/>
@@ -6182,15 +5846,15 @@
           </a:bodyPr>
           <a:lstStyle/>
           <a:p>
-            <a:pPr algn="ctr"/>
-            <a:r>
-              <a:rPr sz="1200" b="1">
+            <a:pPr algn="r"/>
+            <a:r>
+              <a:rPr sz="1300" b="1">
                 <a:solidFill>
                   <a:srgbClr val="000000"/>
                 </a:solidFill>
                 <a:latin typeface="Arial"/>
               </a:rPr>
-              <a:t>DATATHON 2026  ·  Round 1 Idea Submission – Template</a:t>
+              <a:t>8</a:t>
             </a:r>
           </a:p>
         </p:txBody>
@@ -6198,41 +5862,6 @@
       <p:sp>
         <p:nvSpPr>
           <p:cNvPr id="8" name="TextBox 7"/>
-          <p:cNvSpPr txBox="1"/>
-          <p:nvPr/>
-        </p:nvSpPr>
-        <p:spPr>
-          <a:xfrm>
-            <a:off x="10881360" y="6355080"/>
-            <a:ext cx="1005840" cy="502920"/>
-          </a:xfrm>
-          <a:prstGeom prst="rect">
-            <a:avLst/>
-          </a:prstGeom>
-          <a:noFill/>
-        </p:spPr>
-        <p:txBody>
-          <a:bodyPr wrap="square" anchor="ctr">
-            <a:spAutoFit/>
-          </a:bodyPr>
-          <a:lstStyle/>
-          <a:p>
-            <a:pPr algn="r"/>
-            <a:r>
-              <a:rPr sz="1300" b="1">
-                <a:solidFill>
-                  <a:srgbClr val="000000"/>
-                </a:solidFill>
-                <a:latin typeface="Arial"/>
-              </a:rPr>
-              <a:t>8</a:t>
-            </a:r>
-          </a:p>
-        </p:txBody>
-      </p:sp>
-      <p:sp>
-        <p:nvSpPr>
-          <p:cNvPr id="9" name="TextBox 8"/>
           <p:cNvSpPr txBox="1"/>
           <p:nvPr/>
         </p:nvSpPr>
@@ -6276,7 +5905,7 @@
       </p:sp>
       <p:sp>
         <p:nvSpPr>
-          <p:cNvPr id="10" name="TextBox 9"/>
+          <p:cNvPr id="9" name="TextBox 8"/>
           <p:cNvSpPr txBox="1"/>
           <p:nvPr/>
         </p:nvSpPr>

</xml_diff>